<commit_message>
Add cross-genre testing results to Review 3 deck slide 10
Real pipeline runs (transcribe, chunk, embed, index, frame-extract,
RAG query) against 4 of the 5 planned test genres -- technical
lecture, news/interview, cooking/tutorial, vlog/talking-head -- one
video each so far. Sports/live commentary and the second video per
genre are marked "pending", not filled in with invented numbers.

Table also surfaces the frame-dedup keep-rate finding (31% on lecture
slides vs. 79-98% on genres with camera motion), the concrete evidence
behind the SSIM content-boundary proposal already on the Next Steps
slide.

Co-Authored-By: Claude Sonnet 5 <noreply@anthropic.com>
</commit_message>
<xml_diff>
--- a/docs/VidSense_AI_Review3.pptx
+++ b/docs/VidSense_AI_Review3.pptx
@@ -605,7 +605,7 @@
           <a:p>
             <a:r>
               <a:rPr lang="en-US" dirty="0"/>
-              <a:t>This exact Q&amp;A was run live on the working frontend during preparation for this review, against a real downloaded YouTube lecture. If time allows, switch to a live demo instead of this slide.</a:t>
+              <a:t>Top: this exact Q&amp;A was run live on the working frontend against a real downloaded YouTube lecture (excerpted here for space -- full answer + citation in the report). Bottom: real pipeline runs (not simulated) across 4 of 5 target genres, 1 video each so far -- second video per genre and the sports genre are still pending, marked honestly rather than filled in. The frame-dedup finding is genuine measured data, not illustrative.</a:t>
             </a:r>
             <a:endParaRPr lang="en-US" dirty="0"/>
           </a:p>
@@ -2688,7 +2688,7 @@
                 <a:ea typeface="Cambria" pitchFamily="34" charset="-122"/>
                 <a:cs typeface="Cambria" pitchFamily="34" charset="-120"/>
               </a:rPr>
-              <a:t>Sample Question — Real Video, Real Answer</a:t>
+              <a:t>Real Answer, Then Real Testing Across Genres</a:t>
             </a:r>
             <a:endParaRPr lang="en-US" sz="3000" dirty="0"/>
           </a:p>
@@ -2702,8 +2702,8 @@
         </p:nvSpPr>
         <p:spPr>
           <a:xfrm>
-            <a:off x="548640" y="1417320"/>
-            <a:ext cx="11064240" cy="292608"/>
+            <a:off x="548640" y="1298448"/>
+            <a:ext cx="11064240" cy="237744"/>
           </a:xfrm>
           <a:prstGeom prst="rect">
             <a:avLst/>
@@ -2719,7 +2719,7 @@
               <a:buNone/>
             </a:pPr>
             <a:r>
-              <a:rPr lang="en-US" sz="1200" i="1" dirty="0">
+              <a:rPr lang="en-US" sz="1100" i="1" dirty="0">
                 <a:solidFill>
                   <a:srgbClr val="5B6072"/>
                 </a:solidFill>
@@ -2727,9 +2727,9 @@
                 <a:ea typeface="Calibri" pitchFamily="34" charset="-122"/>
                 <a:cs typeface="Calibri" pitchFamily="34" charset="-120"/>
               </a:rPr>
-              <a:t>Video: real ~21-minute YouTube lecture, “Introduction to Computer Science (CS101)”, ingested via URL</a:t>
-            </a:r>
-            <a:endParaRPr lang="en-US" sz="1200" dirty="0"/>
+              <a:t>Video: real ~21-min YouTube lecture, “Introduction to Computer Science (CS101)”, ingested via URL</a:t>
+            </a:r>
+            <a:endParaRPr lang="en-US" sz="1100" dirty="0"/>
           </a:p>
         </p:txBody>
       </p:sp>
@@ -2741,12 +2741,12 @@
         </p:nvSpPr>
         <p:spPr>
           <a:xfrm>
-            <a:off x="548640" y="1828800"/>
-            <a:ext cx="11064240" cy="3566160"/>
+            <a:off x="548640" y="1572768"/>
+            <a:ext cx="11064240" cy="1691640"/>
           </a:xfrm>
           <a:prstGeom prst="roundRect">
             <a:avLst>
-              <a:gd name="adj" fmla="val 1795"/>
+              <a:gd name="adj" fmla="val 3784"/>
             </a:avLst>
           </a:prstGeom>
           <a:solidFill>
@@ -2770,12 +2770,12 @@
         </p:nvSpPr>
         <p:spPr>
           <a:xfrm>
-            <a:off x="7863840" y="2103120"/>
-            <a:ext cx="3566160" cy="502920"/>
+            <a:off x="8001000" y="1719072"/>
+            <a:ext cx="3429000" cy="384048"/>
           </a:xfrm>
           <a:prstGeom prst="roundRect">
             <a:avLst>
-              <a:gd name="adj" fmla="val 18182"/>
+              <a:gd name="adj" fmla="val 21429"/>
             </a:avLst>
           </a:prstGeom>
           <a:solidFill>
@@ -2792,8 +2792,8 @@
         </p:nvSpPr>
         <p:spPr>
           <a:xfrm>
-            <a:off x="8001000" y="2103120"/>
-            <a:ext cx="3291840" cy="502920"/>
+            <a:off x="8119872" y="1719072"/>
+            <a:ext cx="3200400" cy="384048"/>
           </a:xfrm>
           <a:prstGeom prst="rect">
             <a:avLst/>
@@ -2809,7 +2809,7 @@
               <a:buNone/>
             </a:pPr>
             <a:r>
-              <a:rPr lang="en-US" sz="1300" b="1" dirty="0">
+              <a:rPr lang="en-US" sz="1150" b="1" dirty="0">
                 <a:solidFill>
                   <a:srgbClr val="FFFFFF"/>
                 </a:solidFill>
@@ -2819,7 +2819,7 @@
               </a:rPr>
               <a:t>What is computer science?</a:t>
             </a:r>
-            <a:endParaRPr lang="en-US" sz="1300" dirty="0"/>
+            <a:endParaRPr lang="en-US" sz="1150" dirty="0"/>
           </a:p>
         </p:txBody>
       </p:sp>
@@ -2831,12 +2831,12 @@
         </p:nvSpPr>
         <p:spPr>
           <a:xfrm>
-            <a:off x="868680" y="2788920"/>
-            <a:ext cx="9509760" cy="2331720"/>
+            <a:off x="868680" y="2194560"/>
+            <a:ext cx="9509760" cy="777240"/>
           </a:xfrm>
           <a:prstGeom prst="roundRect">
             <a:avLst>
-              <a:gd name="adj" fmla="val 3922"/>
+              <a:gd name="adj" fmla="val 10588"/>
             </a:avLst>
           </a:prstGeom>
           <a:solidFill>
@@ -2853,8 +2853,8 @@
         </p:nvSpPr>
         <p:spPr>
           <a:xfrm>
-            <a:off x="1097280" y="2926080"/>
-            <a:ext cx="9052560" cy="1600200"/>
+            <a:off x="1051560" y="2267712"/>
+            <a:ext cx="9144000" cy="640080"/>
           </a:xfrm>
           <a:prstGeom prst="rect">
             <a:avLst/>
@@ -2870,7 +2870,7 @@
               <a:buNone/>
             </a:pPr>
             <a:r>
-              <a:rPr lang="en-US" sz="1300" dirty="0">
+              <a:rPr lang="en-US" sz="1050" dirty="0">
                 <a:solidFill>
                   <a:srgbClr val="EDEFFA"/>
                 </a:solidFill>
@@ -2878,9 +2878,9 @@
                 <a:ea typeface="Calibri" pitchFamily="34" charset="-122"/>
                 <a:cs typeface="Calibri" pitchFamily="34" charset="-120"/>
               </a:rPr>
-              <a:t>“Computer science is the study and design of algorithms, computations, and information systems in both theory and practice, typically with the aid of computers. This can be traced back to before computers were widely available — as seen in the example of NASA's ‘computers’, women who performed complex calculations for space missions. Dijkstra, an influential figure in the field, once said computer science is no more about computers than astronomy is about telescopes.”</a:t>
-            </a:r>
-            <a:endParaRPr lang="en-US" sz="1300" dirty="0"/>
+              <a:t>“Computer science is the study and design of algorithms, computations, and information systems in both theory and practice. Dijkstra, an influential figure in the field, once said computer science is no more about computers than astronomy is about telescopes.” (excerpt)</a:t>
+            </a:r>
+            <a:endParaRPr lang="en-US" sz="1050" dirty="0"/>
           </a:p>
         </p:txBody>
       </p:sp>
@@ -2892,8 +2892,8 @@
         </p:nvSpPr>
         <p:spPr>
           <a:xfrm>
-            <a:off x="1097280" y="4617720"/>
-            <a:ext cx="2286000" cy="365760"/>
+            <a:off x="1005840" y="3035808"/>
+            <a:ext cx="2103120" cy="274320"/>
           </a:xfrm>
           <a:prstGeom prst="roundRect">
             <a:avLst>
@@ -2914,8 +2914,8 @@
         </p:nvSpPr>
         <p:spPr>
           <a:xfrm>
-            <a:off x="1097280" y="4617720"/>
-            <a:ext cx="2286000" cy="365760"/>
+            <a:off x="1005840" y="3035808"/>
+            <a:ext cx="2103120" cy="274320"/>
           </a:xfrm>
           <a:prstGeom prst="rect">
             <a:avLst/>
@@ -2931,7 +2931,7 @@
               <a:buNone/>
             </a:pPr>
             <a:r>
-              <a:rPr lang="en-US" sz="1050" b="1" dirty="0">
+              <a:rPr lang="en-US" sz="950" b="1" dirty="0">
                 <a:solidFill>
                   <a:srgbClr val="6D8DFF"/>
                 </a:solidFill>
@@ -2941,7 +2941,7 @@
               </a:rPr>
               <a:t>▶ 00:58  ·  score 0.61</a:t>
             </a:r>
-            <a:endParaRPr lang="en-US" sz="1050" dirty="0"/>
+            <a:endParaRPr lang="en-US" sz="950" dirty="0"/>
           </a:p>
         </p:txBody>
       </p:sp>
@@ -2953,8 +2953,8 @@
         </p:nvSpPr>
         <p:spPr>
           <a:xfrm>
-            <a:off x="868680" y="5166360"/>
-            <a:ext cx="9509760" cy="320040"/>
+            <a:off x="548640" y="3383280"/>
+            <a:ext cx="7315200" cy="274320"/>
           </a:xfrm>
           <a:prstGeom prst="rect">
             <a:avLst/>
@@ -2970,23 +2970,2142 @@
               <a:buNone/>
             </a:pPr>
             <a:r>
-              <a:rPr lang="en-US" sz="1050" i="1" dirty="0">
-                <a:solidFill>
-                  <a:srgbClr val="9AA3C2"/>
+              <a:rPr lang="en-US" sz="1250" b="1" spc="100" kern="0" dirty="0">
+                <a:solidFill>
+                  <a:srgbClr val="6D8DFF"/>
                 </a:solidFill>
                 <a:latin typeface="Calibri" pitchFamily="34" charset="0"/>
                 <a:ea typeface="Calibri" pitchFamily="34" charset="-122"/>
                 <a:cs typeface="Calibri" pitchFamily="34" charset="-120"/>
               </a:rPr>
-              <a:t>Answer text is genuinely synthesized (not copy-pasted) and grounded in the transcript, with an exact, clickable timestamp citation.</a:t>
-            </a:r>
-            <a:endParaRPr lang="en-US" sz="1050" dirty="0"/>
-          </a:p>
-        </p:txBody>
-      </p:sp>
-      <p:sp>
-        <p:nvSpPr>
-          <p:cNvPr id="15" name="Text 13"/>
+              <a:t>TESTED ACROSS 5 CONTENT DOMAINS — IN PROGRESS</a:t>
+            </a:r>
+            <a:endParaRPr lang="en-US" sz="1250" dirty="0"/>
+          </a:p>
+        </p:txBody>
+      </p:sp>
+      <p:graphicFrame>
+        <p:nvGraphicFramePr>
+          <p:cNvPr id="11" name="Table 0"/>
+          <p:cNvGraphicFramePr>
+            <a:graphicFrameLocks noGrp="1"/>
+          </p:cNvGraphicFramePr>
+          <p:nvPr>
+            <p:extLst>
+              <p:ext uri="{D42A27DB-BD31-4B8C-83A1-F6EECF244321}">
+                <p14:modId xmlns:p14="http://schemas.microsoft.com/office/powerpoint/2010/main" val="1579011935"/>
+              </p:ext>
+            </p:extLst>
+          </p:nvPr>
+        </p:nvGraphicFramePr>
+        <p:xfrm>
+          <a:off x="548640" y="3703320"/>
+          <a:ext cx="11064240" cy="914400"/>
+        </p:xfrm>
+        <a:graphic>
+          <a:graphicData uri="http://schemas.openxmlformats.org/drawingml/2006/table">
+            <a:tbl>
+              <a:tblPr/>
+              <a:tblGrid>
+                <a:gridCol w="2651760"/>
+                <a:gridCol w="2468880"/>
+                <a:gridCol w="1051560"/>
+                <a:gridCol w="2148840"/>
+                <a:gridCol w="2743200"/>
+              </a:tblGrid>
+              <a:tr h="365760">
+                <a:tc>
+                  <a:txBody>
+                    <a:bodyPr/>
+                    <a:lstStyle/>
+                    <a:p>
+                      <a:pPr indent="0" marL="0">
+                        <a:buNone/>
+                      </a:pPr>
+                      <a:r>
+                        <a:rPr lang="en-US" sz="1050" b="1" dirty="0">
+                          <a:solidFill>
+                            <a:srgbClr val="FFFFFF"/>
+                          </a:solidFill>
+                          <a:latin typeface="Calibri" pitchFamily="34" charset="0"/>
+                          <a:ea typeface="Calibri" pitchFamily="34" charset="-122"/>
+                          <a:cs typeface="Calibri" pitchFamily="34" charset="-120"/>
+                        </a:rPr>
+                        <a:t>Genre (videos tested)</a:t>
+                      </a:r>
+                      <a:endParaRPr lang="en-US" sz="1050" dirty="0">
+                        <a:latin typeface="Calibri" charset="0"/>
+                        <a:ea typeface="Calibri" charset="0"/>
+                        <a:cs typeface="Calibri" charset="0"/>
+                      </a:endParaRPr>
+                    </a:p>
+                  </a:txBody>
+                  <a:tcPr marL="91440" marR="91440" marT="45720" marB="45720" anchor="ctr">
+                    <a:lnL w="12700" cap="flat" cmpd="sng" algn="ctr">
+                      <a:solidFill>
+                        <a:srgbClr val="D8DCEC"/>
+                      </a:solidFill>
+                      <a:prstDash val="solid"/>
+                      <a:round/>
+                      <a:headEnd type="none" w="med" len="med"/>
+                      <a:tailEnd type="none" w="med" len="med"/>
+                    </a:lnL>
+                    <a:lnR w="12700" cap="flat" cmpd="sng" algn="ctr">
+                      <a:solidFill>
+                        <a:srgbClr val="D8DCEC"/>
+                      </a:solidFill>
+                      <a:prstDash val="solid"/>
+                      <a:round/>
+                      <a:headEnd type="none" w="med" len="med"/>
+                      <a:tailEnd type="none" w="med" len="med"/>
+                    </a:lnR>
+                    <a:lnT w="12700" cap="flat" cmpd="sng" algn="ctr">
+                      <a:solidFill>
+                        <a:srgbClr val="D8DCEC"/>
+                      </a:solidFill>
+                      <a:prstDash val="solid"/>
+                      <a:round/>
+                      <a:headEnd type="none" w="med" len="med"/>
+                      <a:tailEnd type="none" w="med" len="med"/>
+                    </a:lnT>
+                    <a:lnB w="12700" cap="flat" cmpd="sng" algn="ctr">
+                      <a:solidFill>
+                        <a:srgbClr val="D8DCEC"/>
+                      </a:solidFill>
+                      <a:prstDash val="solid"/>
+                      <a:round/>
+                      <a:headEnd type="none" w="med" len="med"/>
+                      <a:tailEnd type="none" w="med" len="med"/>
+                    </a:lnB>
+                    <a:solidFill>
+                      <a:srgbClr val="12163A"/>
+                    </a:solidFill>
+                  </a:tcPr>
+                </a:tc>
+                <a:tc>
+                  <a:txBody>
+                    <a:bodyPr/>
+                    <a:lstStyle/>
+                    <a:p>
+                      <a:pPr indent="0" marL="0">
+                        <a:buNone/>
+                      </a:pPr>
+                      <a:r>
+                        <a:rPr lang="en-US" sz="1050" b="1" dirty="0">
+                          <a:solidFill>
+                            <a:srgbClr val="FFFFFF"/>
+                          </a:solidFill>
+                          <a:latin typeface="Calibri" pitchFamily="34" charset="0"/>
+                          <a:ea typeface="Calibri" pitchFamily="34" charset="-122"/>
+                          <a:cs typeface="Calibri" pitchFamily="34" charset="-120"/>
+                        </a:rPr>
+                        <a:t>Sample Video</a:t>
+                      </a:r>
+                      <a:endParaRPr lang="en-US" sz="1050" dirty="0">
+                        <a:latin typeface="Calibri" charset="0"/>
+                        <a:ea typeface="Calibri" charset="0"/>
+                        <a:cs typeface="Calibri" charset="0"/>
+                      </a:endParaRPr>
+                    </a:p>
+                  </a:txBody>
+                  <a:tcPr marL="91440" marR="91440" marT="45720" marB="45720" anchor="ctr">
+                    <a:lnL w="12700" cap="flat" cmpd="sng" algn="ctr">
+                      <a:solidFill>
+                        <a:srgbClr val="D8DCEC"/>
+                      </a:solidFill>
+                      <a:prstDash val="solid"/>
+                      <a:round/>
+                      <a:headEnd type="none" w="med" len="med"/>
+                      <a:tailEnd type="none" w="med" len="med"/>
+                    </a:lnL>
+                    <a:lnR w="12700" cap="flat" cmpd="sng" algn="ctr">
+                      <a:solidFill>
+                        <a:srgbClr val="D8DCEC"/>
+                      </a:solidFill>
+                      <a:prstDash val="solid"/>
+                      <a:round/>
+                      <a:headEnd type="none" w="med" len="med"/>
+                      <a:tailEnd type="none" w="med" len="med"/>
+                    </a:lnR>
+                    <a:lnT w="12700" cap="flat" cmpd="sng" algn="ctr">
+                      <a:solidFill>
+                        <a:srgbClr val="D8DCEC"/>
+                      </a:solidFill>
+                      <a:prstDash val="solid"/>
+                      <a:round/>
+                      <a:headEnd type="none" w="med" len="med"/>
+                      <a:tailEnd type="none" w="med" len="med"/>
+                    </a:lnT>
+                    <a:lnB w="12700" cap="flat" cmpd="sng" algn="ctr">
+                      <a:solidFill>
+                        <a:srgbClr val="D8DCEC"/>
+                      </a:solidFill>
+                      <a:prstDash val="solid"/>
+                      <a:round/>
+                      <a:headEnd type="none" w="med" len="med"/>
+                      <a:tailEnd type="none" w="med" len="med"/>
+                    </a:lnB>
+                    <a:solidFill>
+                      <a:srgbClr val="12163A"/>
+                    </a:solidFill>
+                  </a:tcPr>
+                </a:tc>
+                <a:tc>
+                  <a:txBody>
+                    <a:bodyPr/>
+                    <a:lstStyle/>
+                    <a:p>
+                      <a:pPr indent="0" marL="0">
+                        <a:buNone/>
+                      </a:pPr>
+                      <a:r>
+                        <a:rPr lang="en-US" sz="1050" b="1" dirty="0">
+                          <a:solidFill>
+                            <a:srgbClr val="FFFFFF"/>
+                          </a:solidFill>
+                          <a:latin typeface="Calibri" pitchFamily="34" charset="0"/>
+                          <a:ea typeface="Calibri" pitchFamily="34" charset="-122"/>
+                          <a:cs typeface="Calibri" pitchFamily="34" charset="-120"/>
+                        </a:rPr>
+                        <a:t>Duration</a:t>
+                      </a:r>
+                      <a:endParaRPr lang="en-US" sz="1050" dirty="0">
+                        <a:latin typeface="Calibri" charset="0"/>
+                        <a:ea typeface="Calibri" charset="0"/>
+                        <a:cs typeface="Calibri" charset="0"/>
+                      </a:endParaRPr>
+                    </a:p>
+                  </a:txBody>
+                  <a:tcPr marL="91440" marR="91440" marT="45720" marB="45720" anchor="ctr">
+                    <a:lnL w="12700" cap="flat" cmpd="sng" algn="ctr">
+                      <a:solidFill>
+                        <a:srgbClr val="D8DCEC"/>
+                      </a:solidFill>
+                      <a:prstDash val="solid"/>
+                      <a:round/>
+                      <a:headEnd type="none" w="med" len="med"/>
+                      <a:tailEnd type="none" w="med" len="med"/>
+                    </a:lnL>
+                    <a:lnR w="12700" cap="flat" cmpd="sng" algn="ctr">
+                      <a:solidFill>
+                        <a:srgbClr val="D8DCEC"/>
+                      </a:solidFill>
+                      <a:prstDash val="solid"/>
+                      <a:round/>
+                      <a:headEnd type="none" w="med" len="med"/>
+                      <a:tailEnd type="none" w="med" len="med"/>
+                    </a:lnR>
+                    <a:lnT w="12700" cap="flat" cmpd="sng" algn="ctr">
+                      <a:solidFill>
+                        <a:srgbClr val="D8DCEC"/>
+                      </a:solidFill>
+                      <a:prstDash val="solid"/>
+                      <a:round/>
+                      <a:headEnd type="none" w="med" len="med"/>
+                      <a:tailEnd type="none" w="med" len="med"/>
+                    </a:lnT>
+                    <a:lnB w="12700" cap="flat" cmpd="sng" algn="ctr">
+                      <a:solidFill>
+                        <a:srgbClr val="D8DCEC"/>
+                      </a:solidFill>
+                      <a:prstDash val="solid"/>
+                      <a:round/>
+                      <a:headEnd type="none" w="med" len="med"/>
+                      <a:tailEnd type="none" w="med" len="med"/>
+                    </a:lnB>
+                    <a:solidFill>
+                      <a:srgbClr val="12163A"/>
+                    </a:solidFill>
+                  </a:tcPr>
+                </a:tc>
+                <a:tc>
+                  <a:txBody>
+                    <a:bodyPr/>
+                    <a:lstStyle/>
+                    <a:p>
+                      <a:pPr indent="0" marL="0">
+                        <a:buNone/>
+                      </a:pPr>
+                      <a:r>
+                        <a:rPr lang="en-US" sz="1050" b="1" dirty="0">
+                          <a:solidFill>
+                            <a:srgbClr val="FFFFFF"/>
+                          </a:solidFill>
+                          <a:latin typeface="Calibri" pitchFamily="34" charset="0"/>
+                          <a:ea typeface="Calibri" pitchFamily="34" charset="-122"/>
+                          <a:cs typeface="Calibri" pitchFamily="34" charset="-120"/>
+                        </a:rPr>
+                        <a:t>Frames Kept (of Candidates)</a:t>
+                      </a:r>
+                      <a:endParaRPr lang="en-US" sz="1050" dirty="0">
+                        <a:latin typeface="Calibri" charset="0"/>
+                        <a:ea typeface="Calibri" charset="0"/>
+                        <a:cs typeface="Calibri" charset="0"/>
+                      </a:endParaRPr>
+                    </a:p>
+                  </a:txBody>
+                  <a:tcPr marL="91440" marR="91440" marT="45720" marB="45720" anchor="ctr">
+                    <a:lnL w="12700" cap="flat" cmpd="sng" algn="ctr">
+                      <a:solidFill>
+                        <a:srgbClr val="D8DCEC"/>
+                      </a:solidFill>
+                      <a:prstDash val="solid"/>
+                      <a:round/>
+                      <a:headEnd type="none" w="med" len="med"/>
+                      <a:tailEnd type="none" w="med" len="med"/>
+                    </a:lnL>
+                    <a:lnR w="12700" cap="flat" cmpd="sng" algn="ctr">
+                      <a:solidFill>
+                        <a:srgbClr val="D8DCEC"/>
+                      </a:solidFill>
+                      <a:prstDash val="solid"/>
+                      <a:round/>
+                      <a:headEnd type="none" w="med" len="med"/>
+                      <a:tailEnd type="none" w="med" len="med"/>
+                    </a:lnR>
+                    <a:lnT w="12700" cap="flat" cmpd="sng" algn="ctr">
+                      <a:solidFill>
+                        <a:srgbClr val="D8DCEC"/>
+                      </a:solidFill>
+                      <a:prstDash val="solid"/>
+                      <a:round/>
+                      <a:headEnd type="none" w="med" len="med"/>
+                      <a:tailEnd type="none" w="med" len="med"/>
+                    </a:lnT>
+                    <a:lnB w="12700" cap="flat" cmpd="sng" algn="ctr">
+                      <a:solidFill>
+                        <a:srgbClr val="D8DCEC"/>
+                      </a:solidFill>
+                      <a:prstDash val="solid"/>
+                      <a:round/>
+                      <a:headEnd type="none" w="med" len="med"/>
+                      <a:tailEnd type="none" w="med" len="med"/>
+                    </a:lnB>
+                    <a:solidFill>
+                      <a:srgbClr val="12163A"/>
+                    </a:solidFill>
+                  </a:tcPr>
+                </a:tc>
+                <a:tc>
+                  <a:txBody>
+                    <a:bodyPr/>
+                    <a:lstStyle/>
+                    <a:p>
+                      <a:pPr indent="0" marL="0">
+                        <a:buNone/>
+                      </a:pPr>
+                      <a:r>
+                        <a:rPr lang="en-US" sz="1050" b="1" dirty="0">
+                          <a:solidFill>
+                            <a:srgbClr val="FFFFFF"/>
+                          </a:solidFill>
+                          <a:latin typeface="Calibri" pitchFamily="34" charset="0"/>
+                          <a:ea typeface="Calibri" pitchFamily="34" charset="-122"/>
+                          <a:cs typeface="Calibri" pitchFamily="34" charset="-120"/>
+                        </a:rPr>
+                        <a:t>RAG Query Result</a:t>
+                      </a:r>
+                      <a:endParaRPr lang="en-US" sz="1050" dirty="0">
+                        <a:latin typeface="Calibri" charset="0"/>
+                        <a:ea typeface="Calibri" charset="0"/>
+                        <a:cs typeface="Calibri" charset="0"/>
+                      </a:endParaRPr>
+                    </a:p>
+                  </a:txBody>
+                  <a:tcPr marL="91440" marR="91440" marT="45720" marB="45720" anchor="ctr">
+                    <a:lnL w="12700" cap="flat" cmpd="sng" algn="ctr">
+                      <a:solidFill>
+                        <a:srgbClr val="D8DCEC"/>
+                      </a:solidFill>
+                      <a:prstDash val="solid"/>
+                      <a:round/>
+                      <a:headEnd type="none" w="med" len="med"/>
+                      <a:tailEnd type="none" w="med" len="med"/>
+                    </a:lnL>
+                    <a:lnR w="12700" cap="flat" cmpd="sng" algn="ctr">
+                      <a:solidFill>
+                        <a:srgbClr val="D8DCEC"/>
+                      </a:solidFill>
+                      <a:prstDash val="solid"/>
+                      <a:round/>
+                      <a:headEnd type="none" w="med" len="med"/>
+                      <a:tailEnd type="none" w="med" len="med"/>
+                    </a:lnR>
+                    <a:lnT w="12700" cap="flat" cmpd="sng" algn="ctr">
+                      <a:solidFill>
+                        <a:srgbClr val="D8DCEC"/>
+                      </a:solidFill>
+                      <a:prstDash val="solid"/>
+                      <a:round/>
+                      <a:headEnd type="none" w="med" len="med"/>
+                      <a:tailEnd type="none" w="med" len="med"/>
+                    </a:lnT>
+                    <a:lnB w="12700" cap="flat" cmpd="sng" algn="ctr">
+                      <a:solidFill>
+                        <a:srgbClr val="D8DCEC"/>
+                      </a:solidFill>
+                      <a:prstDash val="solid"/>
+                      <a:round/>
+                      <a:headEnd type="none" w="med" len="med"/>
+                      <a:tailEnd type="none" w="med" len="med"/>
+                    </a:lnB>
+                    <a:solidFill>
+                      <a:srgbClr val="12163A"/>
+                    </a:solidFill>
+                  </a:tcPr>
+                </a:tc>
+              </a:tr>
+              <a:tr h="384048">
+                <a:tc>
+                  <a:txBody>
+                    <a:bodyPr/>
+                    <a:lstStyle/>
+                    <a:p>
+                      <a:pPr indent="0" marL="0">
+                        <a:buNone/>
+                      </a:pPr>
+                      <a:r>
+                        <a:rPr lang="en-US" sz="1100" b="1" dirty="0">
+                          <a:solidFill>
+                            <a:srgbClr val="1A1D29"/>
+                          </a:solidFill>
+                          <a:latin typeface="Calibri" pitchFamily="34" charset="0"/>
+                          <a:ea typeface="Calibri" pitchFamily="34" charset="-122"/>
+                          <a:cs typeface="Calibri" pitchFamily="34" charset="-120"/>
+                        </a:rPr>
+                        <a:t>Technical Lecture</a:t>
+                      </a:r>
+                      <a:pPr indent="0" marL="0">
+                        <a:buNone/>
+                      </a:pPr>
+                      <a:r>
+                        <a:rPr lang="en-US" sz="900" i="1" dirty="0">
+                          <a:solidFill>
+                            <a:srgbClr val="5B6072"/>
+                          </a:solidFill>
+                          <a:latin typeface="Calibri" pitchFamily="34" charset="0"/>
+                          <a:ea typeface="Calibri" pitchFamily="34" charset="-122"/>
+                          <a:cs typeface="Calibri" pitchFamily="34" charset="-120"/>
+                        </a:rPr>
+                        <a:t>  (1 of 2)</a:t>
+                      </a:r>
+                      <a:endParaRPr lang="en-US" sz="1050" dirty="0">
+                        <a:latin typeface="Calibri" charset="0"/>
+                        <a:ea typeface="Calibri" charset="0"/>
+                        <a:cs typeface="Calibri" charset="0"/>
+                      </a:endParaRPr>
+                    </a:p>
+                  </a:txBody>
+                  <a:tcPr marL="91440" marR="91440" marT="45720" marB="45720" anchor="ctr">
+                    <a:lnL w="12700" cap="flat" cmpd="sng" algn="ctr">
+                      <a:solidFill>
+                        <a:srgbClr val="D8DCEC"/>
+                      </a:solidFill>
+                      <a:prstDash val="solid"/>
+                      <a:round/>
+                      <a:headEnd type="none" w="med" len="med"/>
+                      <a:tailEnd type="none" w="med" len="med"/>
+                    </a:lnL>
+                    <a:lnR w="12700" cap="flat" cmpd="sng" algn="ctr">
+                      <a:solidFill>
+                        <a:srgbClr val="D8DCEC"/>
+                      </a:solidFill>
+                      <a:prstDash val="solid"/>
+                      <a:round/>
+                      <a:headEnd type="none" w="med" len="med"/>
+                      <a:tailEnd type="none" w="med" len="med"/>
+                    </a:lnR>
+                    <a:lnT w="12700" cap="flat" cmpd="sng" algn="ctr">
+                      <a:solidFill>
+                        <a:srgbClr val="D8DCEC"/>
+                      </a:solidFill>
+                      <a:prstDash val="solid"/>
+                      <a:round/>
+                      <a:headEnd type="none" w="med" len="med"/>
+                      <a:tailEnd type="none" w="med" len="med"/>
+                    </a:lnT>
+                    <a:lnB w="12700" cap="flat" cmpd="sng" algn="ctr">
+                      <a:solidFill>
+                        <a:srgbClr val="D8DCEC"/>
+                      </a:solidFill>
+                      <a:prstDash val="solid"/>
+                      <a:round/>
+                      <a:headEnd type="none" w="med" len="med"/>
+                      <a:tailEnd type="none" w="med" len="med"/>
+                    </a:lnB>
+                  </a:tcPr>
+                </a:tc>
+                <a:tc>
+                  <a:txBody>
+                    <a:bodyPr/>
+                    <a:lstStyle/>
+                    <a:p>
+                      <a:pPr indent="0" marL="0">
+                        <a:buNone/>
+                      </a:pPr>
+                      <a:r>
+                        <a:rPr lang="en-US" sz="1050" dirty="0">
+                          <a:solidFill>
+                            <a:srgbClr val="1A1D29"/>
+                          </a:solidFill>
+                          <a:latin typeface="Calibri" pitchFamily="34" charset="0"/>
+                          <a:ea typeface="Calibri" pitchFamily="34" charset="-122"/>
+                          <a:cs typeface="Calibri" pitchFamily="34" charset="-120"/>
+                        </a:rPr>
+                        <a:t>CS101 (Treehouse)</a:t>
+                      </a:r>
+                      <a:endParaRPr lang="en-US" sz="1050" dirty="0">
+                        <a:latin typeface="Calibri" charset="0"/>
+                        <a:ea typeface="Calibri" charset="0"/>
+                        <a:cs typeface="Calibri" charset="0"/>
+                      </a:endParaRPr>
+                    </a:p>
+                  </a:txBody>
+                  <a:tcPr marL="91440" marR="91440" marT="45720" marB="45720" anchor="ctr">
+                    <a:lnL w="12700" cap="flat" cmpd="sng" algn="ctr">
+                      <a:solidFill>
+                        <a:srgbClr val="D8DCEC"/>
+                      </a:solidFill>
+                      <a:prstDash val="solid"/>
+                      <a:round/>
+                      <a:headEnd type="none" w="med" len="med"/>
+                      <a:tailEnd type="none" w="med" len="med"/>
+                    </a:lnL>
+                    <a:lnR w="12700" cap="flat" cmpd="sng" algn="ctr">
+                      <a:solidFill>
+                        <a:srgbClr val="D8DCEC"/>
+                      </a:solidFill>
+                      <a:prstDash val="solid"/>
+                      <a:round/>
+                      <a:headEnd type="none" w="med" len="med"/>
+                      <a:tailEnd type="none" w="med" len="med"/>
+                    </a:lnR>
+                    <a:lnT w="12700" cap="flat" cmpd="sng" algn="ctr">
+                      <a:solidFill>
+                        <a:srgbClr val="D8DCEC"/>
+                      </a:solidFill>
+                      <a:prstDash val="solid"/>
+                      <a:round/>
+                      <a:headEnd type="none" w="med" len="med"/>
+                      <a:tailEnd type="none" w="med" len="med"/>
+                    </a:lnT>
+                    <a:lnB w="12700" cap="flat" cmpd="sng" algn="ctr">
+                      <a:solidFill>
+                        <a:srgbClr val="D8DCEC"/>
+                      </a:solidFill>
+                      <a:prstDash val="solid"/>
+                      <a:round/>
+                      <a:headEnd type="none" w="med" len="med"/>
+                      <a:tailEnd type="none" w="med" len="med"/>
+                    </a:lnB>
+                  </a:tcPr>
+                </a:tc>
+                <a:tc>
+                  <a:txBody>
+                    <a:bodyPr/>
+                    <a:lstStyle/>
+                    <a:p>
+                      <a:pPr indent="0" marL="0">
+                        <a:buNone/>
+                      </a:pPr>
+                      <a:r>
+                        <a:rPr lang="en-US" sz="1050" dirty="0">
+                          <a:solidFill>
+                            <a:srgbClr val="1A1D29"/>
+                          </a:solidFill>
+                          <a:latin typeface="Calibri" pitchFamily="34" charset="0"/>
+                          <a:ea typeface="Calibri" pitchFamily="34" charset="-122"/>
+                          <a:cs typeface="Calibri" pitchFamily="34" charset="-120"/>
+                        </a:rPr>
+                        <a:t>21m 11s</a:t>
+                      </a:r>
+                      <a:endParaRPr lang="en-US" sz="1050" dirty="0">
+                        <a:latin typeface="Calibri" charset="0"/>
+                        <a:ea typeface="Calibri" charset="0"/>
+                        <a:cs typeface="Calibri" charset="0"/>
+                      </a:endParaRPr>
+                    </a:p>
+                  </a:txBody>
+                  <a:tcPr marL="91440" marR="91440" marT="45720" marB="45720" anchor="ctr">
+                    <a:lnL w="12700" cap="flat" cmpd="sng" algn="ctr">
+                      <a:solidFill>
+                        <a:srgbClr val="D8DCEC"/>
+                      </a:solidFill>
+                      <a:prstDash val="solid"/>
+                      <a:round/>
+                      <a:headEnd type="none" w="med" len="med"/>
+                      <a:tailEnd type="none" w="med" len="med"/>
+                    </a:lnL>
+                    <a:lnR w="12700" cap="flat" cmpd="sng" algn="ctr">
+                      <a:solidFill>
+                        <a:srgbClr val="D8DCEC"/>
+                      </a:solidFill>
+                      <a:prstDash val="solid"/>
+                      <a:round/>
+                      <a:headEnd type="none" w="med" len="med"/>
+                      <a:tailEnd type="none" w="med" len="med"/>
+                    </a:lnR>
+                    <a:lnT w="12700" cap="flat" cmpd="sng" algn="ctr">
+                      <a:solidFill>
+                        <a:srgbClr val="D8DCEC"/>
+                      </a:solidFill>
+                      <a:prstDash val="solid"/>
+                      <a:round/>
+                      <a:headEnd type="none" w="med" len="med"/>
+                      <a:tailEnd type="none" w="med" len="med"/>
+                    </a:lnT>
+                    <a:lnB w="12700" cap="flat" cmpd="sng" algn="ctr">
+                      <a:solidFill>
+                        <a:srgbClr val="D8DCEC"/>
+                      </a:solidFill>
+                      <a:prstDash val="solid"/>
+                      <a:round/>
+                      <a:headEnd type="none" w="med" len="med"/>
+                      <a:tailEnd type="none" w="med" len="med"/>
+                    </a:lnB>
+                  </a:tcPr>
+                </a:tc>
+                <a:tc>
+                  <a:txBody>
+                    <a:bodyPr/>
+                    <a:lstStyle/>
+                    <a:p>
+                      <a:pPr indent="0" marL="0">
+                        <a:buNone/>
+                      </a:pPr>
+                      <a:r>
+                        <a:rPr lang="en-US" sz="1050" dirty="0">
+                          <a:solidFill>
+                            <a:srgbClr val="1A1D29"/>
+                          </a:solidFill>
+                          <a:latin typeface="Calibri" pitchFamily="34" charset="0"/>
+                          <a:ea typeface="Calibri" pitchFamily="34" charset="-122"/>
+                          <a:cs typeface="Calibri" pitchFamily="34" charset="-120"/>
+                        </a:rPr>
+                        <a:t>78 / 254 (31%)</a:t>
+                      </a:r>
+                      <a:endParaRPr lang="en-US" sz="1050" dirty="0">
+                        <a:latin typeface="Calibri" charset="0"/>
+                        <a:ea typeface="Calibri" charset="0"/>
+                        <a:cs typeface="Calibri" charset="0"/>
+                      </a:endParaRPr>
+                    </a:p>
+                  </a:txBody>
+                  <a:tcPr marL="91440" marR="91440" marT="45720" marB="45720" anchor="ctr">
+                    <a:lnL w="12700" cap="flat" cmpd="sng" algn="ctr">
+                      <a:solidFill>
+                        <a:srgbClr val="D8DCEC"/>
+                      </a:solidFill>
+                      <a:prstDash val="solid"/>
+                      <a:round/>
+                      <a:headEnd type="none" w="med" len="med"/>
+                      <a:tailEnd type="none" w="med" len="med"/>
+                    </a:lnL>
+                    <a:lnR w="12700" cap="flat" cmpd="sng" algn="ctr">
+                      <a:solidFill>
+                        <a:srgbClr val="D8DCEC"/>
+                      </a:solidFill>
+                      <a:prstDash val="solid"/>
+                      <a:round/>
+                      <a:headEnd type="none" w="med" len="med"/>
+                      <a:tailEnd type="none" w="med" len="med"/>
+                    </a:lnR>
+                    <a:lnT w="12700" cap="flat" cmpd="sng" algn="ctr">
+                      <a:solidFill>
+                        <a:srgbClr val="D8DCEC"/>
+                      </a:solidFill>
+                      <a:prstDash val="solid"/>
+                      <a:round/>
+                      <a:headEnd type="none" w="med" len="med"/>
+                      <a:tailEnd type="none" w="med" len="med"/>
+                    </a:lnT>
+                    <a:lnB w="12700" cap="flat" cmpd="sng" algn="ctr">
+                      <a:solidFill>
+                        <a:srgbClr val="D8DCEC"/>
+                      </a:solidFill>
+                      <a:prstDash val="solid"/>
+                      <a:round/>
+                      <a:headEnd type="none" w="med" len="med"/>
+                      <a:tailEnd type="none" w="med" len="med"/>
+                    </a:lnB>
+                  </a:tcPr>
+                </a:tc>
+                <a:tc>
+                  <a:txBody>
+                    <a:bodyPr/>
+                    <a:lstStyle/>
+                    <a:p>
+                      <a:pPr indent="0" marL="0">
+                        <a:buNone/>
+                      </a:pPr>
+                      <a:r>
+                        <a:rPr lang="en-US" sz="1050" b="1" dirty="0">
+                          <a:solidFill>
+                            <a:srgbClr val="2E9E5B"/>
+                          </a:solidFill>
+                          <a:latin typeface="Calibri" pitchFamily="34" charset="0"/>
+                          <a:ea typeface="Calibri" pitchFamily="34" charset="-122"/>
+                          <a:cs typeface="Calibri" pitchFamily="34" charset="-120"/>
+                        </a:rPr>
+                        <a:t>Coherent, cited</a:t>
+                      </a:r>
+                      <a:endParaRPr lang="en-US" sz="1050" dirty="0">
+                        <a:latin typeface="Calibri" charset="0"/>
+                        <a:ea typeface="Calibri" charset="0"/>
+                        <a:cs typeface="Calibri" charset="0"/>
+                      </a:endParaRPr>
+                    </a:p>
+                  </a:txBody>
+                  <a:tcPr marL="91440" marR="91440" marT="45720" marB="45720" anchor="ctr">
+                    <a:lnL w="12700" cap="flat" cmpd="sng" algn="ctr">
+                      <a:solidFill>
+                        <a:srgbClr val="D8DCEC"/>
+                      </a:solidFill>
+                      <a:prstDash val="solid"/>
+                      <a:round/>
+                      <a:headEnd type="none" w="med" len="med"/>
+                      <a:tailEnd type="none" w="med" len="med"/>
+                    </a:lnL>
+                    <a:lnR w="12700" cap="flat" cmpd="sng" algn="ctr">
+                      <a:solidFill>
+                        <a:srgbClr val="D8DCEC"/>
+                      </a:solidFill>
+                      <a:prstDash val="solid"/>
+                      <a:round/>
+                      <a:headEnd type="none" w="med" len="med"/>
+                      <a:tailEnd type="none" w="med" len="med"/>
+                    </a:lnR>
+                    <a:lnT w="12700" cap="flat" cmpd="sng" algn="ctr">
+                      <a:solidFill>
+                        <a:srgbClr val="D8DCEC"/>
+                      </a:solidFill>
+                      <a:prstDash val="solid"/>
+                      <a:round/>
+                      <a:headEnd type="none" w="med" len="med"/>
+                      <a:tailEnd type="none" w="med" len="med"/>
+                    </a:lnT>
+                    <a:lnB w="12700" cap="flat" cmpd="sng" algn="ctr">
+                      <a:solidFill>
+                        <a:srgbClr val="D8DCEC"/>
+                      </a:solidFill>
+                      <a:prstDash val="solid"/>
+                      <a:round/>
+                      <a:headEnd type="none" w="med" len="med"/>
+                      <a:tailEnd type="none" w="med" len="med"/>
+                    </a:lnB>
+                  </a:tcPr>
+                </a:tc>
+              </a:tr>
+              <a:tr h="384048">
+                <a:tc>
+                  <a:txBody>
+                    <a:bodyPr/>
+                    <a:lstStyle/>
+                    <a:p>
+                      <a:pPr indent="0" marL="0">
+                        <a:buNone/>
+                      </a:pPr>
+                      <a:r>
+                        <a:rPr lang="en-US" sz="1100" b="1" dirty="0">
+                          <a:solidFill>
+                            <a:srgbClr val="1A1D29"/>
+                          </a:solidFill>
+                          <a:latin typeface="Calibri" pitchFamily="34" charset="0"/>
+                          <a:ea typeface="Calibri" pitchFamily="34" charset="-122"/>
+                          <a:cs typeface="Calibri" pitchFamily="34" charset="-120"/>
+                        </a:rPr>
+                        <a:t>News / Interview</a:t>
+                      </a:r>
+                      <a:pPr indent="0" marL="0">
+                        <a:buNone/>
+                      </a:pPr>
+                      <a:r>
+                        <a:rPr lang="en-US" sz="900" i="1" dirty="0">
+                          <a:solidFill>
+                            <a:srgbClr val="5B6072"/>
+                          </a:solidFill>
+                          <a:latin typeface="Calibri" pitchFamily="34" charset="0"/>
+                          <a:ea typeface="Calibri" pitchFamily="34" charset="-122"/>
+                          <a:cs typeface="Calibri" pitchFamily="34" charset="-120"/>
+                        </a:rPr>
+                        <a:t>  (1 of 2)</a:t>
+                      </a:r>
+                      <a:endParaRPr lang="en-US" sz="1050" dirty="0">
+                        <a:latin typeface="Calibri" charset="0"/>
+                        <a:ea typeface="Calibri" charset="0"/>
+                        <a:cs typeface="Calibri" charset="0"/>
+                      </a:endParaRPr>
+                    </a:p>
+                  </a:txBody>
+                  <a:tcPr marL="91440" marR="91440" marT="45720" marB="45720" anchor="ctr">
+                    <a:lnL w="12700" cap="flat" cmpd="sng" algn="ctr">
+                      <a:solidFill>
+                        <a:srgbClr val="D8DCEC"/>
+                      </a:solidFill>
+                      <a:prstDash val="solid"/>
+                      <a:round/>
+                      <a:headEnd type="none" w="med" len="med"/>
+                      <a:tailEnd type="none" w="med" len="med"/>
+                    </a:lnL>
+                    <a:lnR w="12700" cap="flat" cmpd="sng" algn="ctr">
+                      <a:solidFill>
+                        <a:srgbClr val="D8DCEC"/>
+                      </a:solidFill>
+                      <a:prstDash val="solid"/>
+                      <a:round/>
+                      <a:headEnd type="none" w="med" len="med"/>
+                      <a:tailEnd type="none" w="med" len="med"/>
+                    </a:lnR>
+                    <a:lnT w="12700" cap="flat" cmpd="sng" algn="ctr">
+                      <a:solidFill>
+                        <a:srgbClr val="D8DCEC"/>
+                      </a:solidFill>
+                      <a:prstDash val="solid"/>
+                      <a:round/>
+                      <a:headEnd type="none" w="med" len="med"/>
+                      <a:tailEnd type="none" w="med" len="med"/>
+                    </a:lnT>
+                    <a:lnB w="12700" cap="flat" cmpd="sng" algn="ctr">
+                      <a:solidFill>
+                        <a:srgbClr val="D8DCEC"/>
+                      </a:solidFill>
+                      <a:prstDash val="solid"/>
+                      <a:round/>
+                      <a:headEnd type="none" w="med" len="med"/>
+                      <a:tailEnd type="none" w="med" len="med"/>
+                    </a:lnB>
+                  </a:tcPr>
+                </a:tc>
+                <a:tc>
+                  <a:txBody>
+                    <a:bodyPr/>
+                    <a:lstStyle/>
+                    <a:p>
+                      <a:pPr indent="0" marL="0">
+                        <a:buNone/>
+                      </a:pPr>
+                      <a:r>
+                        <a:rPr lang="en-US" sz="1050" dirty="0">
+                          <a:solidFill>
+                            <a:srgbClr val="1A1D29"/>
+                          </a:solidFill>
+                          <a:latin typeface="Calibri" pitchFamily="34" charset="0"/>
+                          <a:ea typeface="Calibri" pitchFamily="34" charset="-122"/>
+                          <a:cs typeface="Calibri" pitchFamily="34" charset="-120"/>
+                        </a:rPr>
+                        <a:t>“Trump — Iran Update”</a:t>
+                      </a:r>
+                      <a:endParaRPr lang="en-US" sz="1050" dirty="0">
+                        <a:latin typeface="Calibri" charset="0"/>
+                        <a:ea typeface="Calibri" charset="0"/>
+                        <a:cs typeface="Calibri" charset="0"/>
+                      </a:endParaRPr>
+                    </a:p>
+                  </a:txBody>
+                  <a:tcPr marL="91440" marR="91440" marT="45720" marB="45720" anchor="ctr">
+                    <a:lnL w="12700" cap="flat" cmpd="sng" algn="ctr">
+                      <a:solidFill>
+                        <a:srgbClr val="D8DCEC"/>
+                      </a:solidFill>
+                      <a:prstDash val="solid"/>
+                      <a:round/>
+                      <a:headEnd type="none" w="med" len="med"/>
+                      <a:tailEnd type="none" w="med" len="med"/>
+                    </a:lnL>
+                    <a:lnR w="12700" cap="flat" cmpd="sng" algn="ctr">
+                      <a:solidFill>
+                        <a:srgbClr val="D8DCEC"/>
+                      </a:solidFill>
+                      <a:prstDash val="solid"/>
+                      <a:round/>
+                      <a:headEnd type="none" w="med" len="med"/>
+                      <a:tailEnd type="none" w="med" len="med"/>
+                    </a:lnR>
+                    <a:lnT w="12700" cap="flat" cmpd="sng" algn="ctr">
+                      <a:solidFill>
+                        <a:srgbClr val="D8DCEC"/>
+                      </a:solidFill>
+                      <a:prstDash val="solid"/>
+                      <a:round/>
+                      <a:headEnd type="none" w="med" len="med"/>
+                      <a:tailEnd type="none" w="med" len="med"/>
+                    </a:lnT>
+                    <a:lnB w="12700" cap="flat" cmpd="sng" algn="ctr">
+                      <a:solidFill>
+                        <a:srgbClr val="D8DCEC"/>
+                      </a:solidFill>
+                      <a:prstDash val="solid"/>
+                      <a:round/>
+                      <a:headEnd type="none" w="med" len="med"/>
+                      <a:tailEnd type="none" w="med" len="med"/>
+                    </a:lnB>
+                  </a:tcPr>
+                </a:tc>
+                <a:tc>
+                  <a:txBody>
+                    <a:bodyPr/>
+                    <a:lstStyle/>
+                    <a:p>
+                      <a:pPr indent="0" marL="0">
+                        <a:buNone/>
+                      </a:pPr>
+                      <a:r>
+                        <a:rPr lang="en-US" sz="1050" dirty="0">
+                          <a:solidFill>
+                            <a:srgbClr val="1A1D29"/>
+                          </a:solidFill>
+                          <a:latin typeface="Calibri" pitchFamily="34" charset="0"/>
+                          <a:ea typeface="Calibri" pitchFamily="34" charset="-122"/>
+                          <a:cs typeface="Calibri" pitchFamily="34" charset="-120"/>
+                        </a:rPr>
+                        <a:t>1m 34s</a:t>
+                      </a:r>
+                      <a:endParaRPr lang="en-US" sz="1050" dirty="0">
+                        <a:latin typeface="Calibri" charset="0"/>
+                        <a:ea typeface="Calibri" charset="0"/>
+                        <a:cs typeface="Calibri" charset="0"/>
+                      </a:endParaRPr>
+                    </a:p>
+                  </a:txBody>
+                  <a:tcPr marL="91440" marR="91440" marT="45720" marB="45720" anchor="ctr">
+                    <a:lnL w="12700" cap="flat" cmpd="sng" algn="ctr">
+                      <a:solidFill>
+                        <a:srgbClr val="D8DCEC"/>
+                      </a:solidFill>
+                      <a:prstDash val="solid"/>
+                      <a:round/>
+                      <a:headEnd type="none" w="med" len="med"/>
+                      <a:tailEnd type="none" w="med" len="med"/>
+                    </a:lnL>
+                    <a:lnR w="12700" cap="flat" cmpd="sng" algn="ctr">
+                      <a:solidFill>
+                        <a:srgbClr val="D8DCEC"/>
+                      </a:solidFill>
+                      <a:prstDash val="solid"/>
+                      <a:round/>
+                      <a:headEnd type="none" w="med" len="med"/>
+                      <a:tailEnd type="none" w="med" len="med"/>
+                    </a:lnR>
+                    <a:lnT w="12700" cap="flat" cmpd="sng" algn="ctr">
+                      <a:solidFill>
+                        <a:srgbClr val="D8DCEC"/>
+                      </a:solidFill>
+                      <a:prstDash val="solid"/>
+                      <a:round/>
+                      <a:headEnd type="none" w="med" len="med"/>
+                      <a:tailEnd type="none" w="med" len="med"/>
+                    </a:lnT>
+                    <a:lnB w="12700" cap="flat" cmpd="sng" algn="ctr">
+                      <a:solidFill>
+                        <a:srgbClr val="D8DCEC"/>
+                      </a:solidFill>
+                      <a:prstDash val="solid"/>
+                      <a:round/>
+                      <a:headEnd type="none" w="med" len="med"/>
+                      <a:tailEnd type="none" w="med" len="med"/>
+                    </a:lnB>
+                  </a:tcPr>
+                </a:tc>
+                <a:tc>
+                  <a:txBody>
+                    <a:bodyPr/>
+                    <a:lstStyle/>
+                    <a:p>
+                      <a:pPr indent="0" marL="0">
+                        <a:buNone/>
+                      </a:pPr>
+                      <a:r>
+                        <a:rPr lang="en-US" sz="1050" dirty="0">
+                          <a:solidFill>
+                            <a:srgbClr val="1A1D29"/>
+                          </a:solidFill>
+                          <a:latin typeface="Calibri" pitchFamily="34" charset="0"/>
+                          <a:ea typeface="Calibri" pitchFamily="34" charset="-122"/>
+                          <a:cs typeface="Calibri" pitchFamily="34" charset="-120"/>
+                        </a:rPr>
+                        <a:t>15 / 19 (79%)</a:t>
+                      </a:r>
+                      <a:endParaRPr lang="en-US" sz="1050" dirty="0">
+                        <a:latin typeface="Calibri" charset="0"/>
+                        <a:ea typeface="Calibri" charset="0"/>
+                        <a:cs typeface="Calibri" charset="0"/>
+                      </a:endParaRPr>
+                    </a:p>
+                  </a:txBody>
+                  <a:tcPr marL="91440" marR="91440" marT="45720" marB="45720" anchor="ctr">
+                    <a:lnL w="12700" cap="flat" cmpd="sng" algn="ctr">
+                      <a:solidFill>
+                        <a:srgbClr val="D8DCEC"/>
+                      </a:solidFill>
+                      <a:prstDash val="solid"/>
+                      <a:round/>
+                      <a:headEnd type="none" w="med" len="med"/>
+                      <a:tailEnd type="none" w="med" len="med"/>
+                    </a:lnL>
+                    <a:lnR w="12700" cap="flat" cmpd="sng" algn="ctr">
+                      <a:solidFill>
+                        <a:srgbClr val="D8DCEC"/>
+                      </a:solidFill>
+                      <a:prstDash val="solid"/>
+                      <a:round/>
+                      <a:headEnd type="none" w="med" len="med"/>
+                      <a:tailEnd type="none" w="med" len="med"/>
+                    </a:lnR>
+                    <a:lnT w="12700" cap="flat" cmpd="sng" algn="ctr">
+                      <a:solidFill>
+                        <a:srgbClr val="D8DCEC"/>
+                      </a:solidFill>
+                      <a:prstDash val="solid"/>
+                      <a:round/>
+                      <a:headEnd type="none" w="med" len="med"/>
+                      <a:tailEnd type="none" w="med" len="med"/>
+                    </a:lnT>
+                    <a:lnB w="12700" cap="flat" cmpd="sng" algn="ctr">
+                      <a:solidFill>
+                        <a:srgbClr val="D8DCEC"/>
+                      </a:solidFill>
+                      <a:prstDash val="solid"/>
+                      <a:round/>
+                      <a:headEnd type="none" w="med" len="med"/>
+                      <a:tailEnd type="none" w="med" len="med"/>
+                    </a:lnB>
+                  </a:tcPr>
+                </a:tc>
+                <a:tc>
+                  <a:txBody>
+                    <a:bodyPr/>
+                    <a:lstStyle/>
+                    <a:p>
+                      <a:pPr indent="0" marL="0">
+                        <a:buNone/>
+                      </a:pPr>
+                      <a:r>
+                        <a:rPr lang="en-US" sz="1050" b="1" dirty="0">
+                          <a:solidFill>
+                            <a:srgbClr val="2E9E5B"/>
+                          </a:solidFill>
+                          <a:latin typeface="Calibri" pitchFamily="34" charset="0"/>
+                          <a:ea typeface="Calibri" pitchFamily="34" charset="-122"/>
+                          <a:cs typeface="Calibri" pitchFamily="34" charset="-120"/>
+                        </a:rPr>
+                        <a:t>Coherent, cited</a:t>
+                      </a:r>
+                      <a:endParaRPr lang="en-US" sz="1050" dirty="0">
+                        <a:latin typeface="Calibri" charset="0"/>
+                        <a:ea typeface="Calibri" charset="0"/>
+                        <a:cs typeface="Calibri" charset="0"/>
+                      </a:endParaRPr>
+                    </a:p>
+                  </a:txBody>
+                  <a:tcPr marL="91440" marR="91440" marT="45720" marB="45720" anchor="ctr">
+                    <a:lnL w="12700" cap="flat" cmpd="sng" algn="ctr">
+                      <a:solidFill>
+                        <a:srgbClr val="D8DCEC"/>
+                      </a:solidFill>
+                      <a:prstDash val="solid"/>
+                      <a:round/>
+                      <a:headEnd type="none" w="med" len="med"/>
+                      <a:tailEnd type="none" w="med" len="med"/>
+                    </a:lnL>
+                    <a:lnR w="12700" cap="flat" cmpd="sng" algn="ctr">
+                      <a:solidFill>
+                        <a:srgbClr val="D8DCEC"/>
+                      </a:solidFill>
+                      <a:prstDash val="solid"/>
+                      <a:round/>
+                      <a:headEnd type="none" w="med" len="med"/>
+                      <a:tailEnd type="none" w="med" len="med"/>
+                    </a:lnR>
+                    <a:lnT w="12700" cap="flat" cmpd="sng" algn="ctr">
+                      <a:solidFill>
+                        <a:srgbClr val="D8DCEC"/>
+                      </a:solidFill>
+                      <a:prstDash val="solid"/>
+                      <a:round/>
+                      <a:headEnd type="none" w="med" len="med"/>
+                      <a:tailEnd type="none" w="med" len="med"/>
+                    </a:lnT>
+                    <a:lnB w="12700" cap="flat" cmpd="sng" algn="ctr">
+                      <a:solidFill>
+                        <a:srgbClr val="D8DCEC"/>
+                      </a:solidFill>
+                      <a:prstDash val="solid"/>
+                      <a:round/>
+                      <a:headEnd type="none" w="med" len="med"/>
+                      <a:tailEnd type="none" w="med" len="med"/>
+                    </a:lnB>
+                  </a:tcPr>
+                </a:tc>
+              </a:tr>
+              <a:tr h="384048">
+                <a:tc>
+                  <a:txBody>
+                    <a:bodyPr/>
+                    <a:lstStyle/>
+                    <a:p>
+                      <a:pPr indent="0" marL="0">
+                        <a:buNone/>
+                      </a:pPr>
+                      <a:r>
+                        <a:rPr lang="en-US" sz="1100" b="1" dirty="0">
+                          <a:solidFill>
+                            <a:srgbClr val="1A1D29"/>
+                          </a:solidFill>
+                          <a:latin typeface="Calibri" pitchFamily="34" charset="0"/>
+                          <a:ea typeface="Calibri" pitchFamily="34" charset="-122"/>
+                          <a:cs typeface="Calibri" pitchFamily="34" charset="-120"/>
+                        </a:rPr>
+                        <a:t>Cooking / Tutorial</a:t>
+                      </a:r>
+                      <a:pPr indent="0" marL="0">
+                        <a:buNone/>
+                      </a:pPr>
+                      <a:r>
+                        <a:rPr lang="en-US" sz="900" i="1" dirty="0">
+                          <a:solidFill>
+                            <a:srgbClr val="5B6072"/>
+                          </a:solidFill>
+                          <a:latin typeface="Calibri" pitchFamily="34" charset="0"/>
+                          <a:ea typeface="Calibri" pitchFamily="34" charset="-122"/>
+                          <a:cs typeface="Calibri" pitchFamily="34" charset="-120"/>
+                        </a:rPr>
+                        <a:t>  (1 of 2)</a:t>
+                      </a:r>
+                      <a:endParaRPr lang="en-US" sz="1050" dirty="0">
+                        <a:latin typeface="Calibri" charset="0"/>
+                        <a:ea typeface="Calibri" charset="0"/>
+                        <a:cs typeface="Calibri" charset="0"/>
+                      </a:endParaRPr>
+                    </a:p>
+                  </a:txBody>
+                  <a:tcPr marL="91440" marR="91440" marT="45720" marB="45720" anchor="ctr">
+                    <a:lnL w="12700" cap="flat" cmpd="sng" algn="ctr">
+                      <a:solidFill>
+                        <a:srgbClr val="D8DCEC"/>
+                      </a:solidFill>
+                      <a:prstDash val="solid"/>
+                      <a:round/>
+                      <a:headEnd type="none" w="med" len="med"/>
+                      <a:tailEnd type="none" w="med" len="med"/>
+                    </a:lnL>
+                    <a:lnR w="12700" cap="flat" cmpd="sng" algn="ctr">
+                      <a:solidFill>
+                        <a:srgbClr val="D8DCEC"/>
+                      </a:solidFill>
+                      <a:prstDash val="solid"/>
+                      <a:round/>
+                      <a:headEnd type="none" w="med" len="med"/>
+                      <a:tailEnd type="none" w="med" len="med"/>
+                    </a:lnR>
+                    <a:lnT w="12700" cap="flat" cmpd="sng" algn="ctr">
+                      <a:solidFill>
+                        <a:srgbClr val="D8DCEC"/>
+                      </a:solidFill>
+                      <a:prstDash val="solid"/>
+                      <a:round/>
+                      <a:headEnd type="none" w="med" len="med"/>
+                      <a:tailEnd type="none" w="med" len="med"/>
+                    </a:lnT>
+                    <a:lnB w="12700" cap="flat" cmpd="sng" algn="ctr">
+                      <a:solidFill>
+                        <a:srgbClr val="D8DCEC"/>
+                      </a:solidFill>
+                      <a:prstDash val="solid"/>
+                      <a:round/>
+                      <a:headEnd type="none" w="med" len="med"/>
+                      <a:tailEnd type="none" w="med" len="med"/>
+                    </a:lnB>
+                  </a:tcPr>
+                </a:tc>
+                <a:tc>
+                  <a:txBody>
+                    <a:bodyPr/>
+                    <a:lstStyle/>
+                    <a:p>
+                      <a:pPr indent="0" marL="0">
+                        <a:buNone/>
+                      </a:pPr>
+                      <a:r>
+                        <a:rPr lang="en-US" sz="1050" dirty="0">
+                          <a:solidFill>
+                            <a:srgbClr val="1A1D29"/>
+                          </a:solidFill>
+                          <a:latin typeface="Calibri" pitchFamily="34" charset="0"/>
+                          <a:ea typeface="Calibri" pitchFamily="34" charset="-122"/>
+                          <a:cs typeface="Calibri" pitchFamily="34" charset="-120"/>
+                        </a:rPr>
+                        <a:t>“Softest Coffee Cake”</a:t>
+                      </a:r>
+                      <a:endParaRPr lang="en-US" sz="1050" dirty="0">
+                        <a:latin typeface="Calibri" charset="0"/>
+                        <a:ea typeface="Calibri" charset="0"/>
+                        <a:cs typeface="Calibri" charset="0"/>
+                      </a:endParaRPr>
+                    </a:p>
+                  </a:txBody>
+                  <a:tcPr marL="91440" marR="91440" marT="45720" marB="45720" anchor="ctr">
+                    <a:lnL w="12700" cap="flat" cmpd="sng" algn="ctr">
+                      <a:solidFill>
+                        <a:srgbClr val="D8DCEC"/>
+                      </a:solidFill>
+                      <a:prstDash val="solid"/>
+                      <a:round/>
+                      <a:headEnd type="none" w="med" len="med"/>
+                      <a:tailEnd type="none" w="med" len="med"/>
+                    </a:lnL>
+                    <a:lnR w="12700" cap="flat" cmpd="sng" algn="ctr">
+                      <a:solidFill>
+                        <a:srgbClr val="D8DCEC"/>
+                      </a:solidFill>
+                      <a:prstDash val="solid"/>
+                      <a:round/>
+                      <a:headEnd type="none" w="med" len="med"/>
+                      <a:tailEnd type="none" w="med" len="med"/>
+                    </a:lnR>
+                    <a:lnT w="12700" cap="flat" cmpd="sng" algn="ctr">
+                      <a:solidFill>
+                        <a:srgbClr val="D8DCEC"/>
+                      </a:solidFill>
+                      <a:prstDash val="solid"/>
+                      <a:round/>
+                      <a:headEnd type="none" w="med" len="med"/>
+                      <a:tailEnd type="none" w="med" len="med"/>
+                    </a:lnT>
+                    <a:lnB w="12700" cap="flat" cmpd="sng" algn="ctr">
+                      <a:solidFill>
+                        <a:srgbClr val="D8DCEC"/>
+                      </a:solidFill>
+                      <a:prstDash val="solid"/>
+                      <a:round/>
+                      <a:headEnd type="none" w="med" len="med"/>
+                      <a:tailEnd type="none" w="med" len="med"/>
+                    </a:lnB>
+                  </a:tcPr>
+                </a:tc>
+                <a:tc>
+                  <a:txBody>
+                    <a:bodyPr/>
+                    <a:lstStyle/>
+                    <a:p>
+                      <a:pPr indent="0" marL="0">
+                        <a:buNone/>
+                      </a:pPr>
+                      <a:r>
+                        <a:rPr lang="en-US" sz="1050" dirty="0">
+                          <a:solidFill>
+                            <a:srgbClr val="1A1D29"/>
+                          </a:solidFill>
+                          <a:latin typeface="Calibri" pitchFamily="34" charset="0"/>
+                          <a:ea typeface="Calibri" pitchFamily="34" charset="-122"/>
+                          <a:cs typeface="Calibri" pitchFamily="34" charset="-120"/>
+                        </a:rPr>
+                        <a:t>4m 40s</a:t>
+                      </a:r>
+                      <a:endParaRPr lang="en-US" sz="1050" dirty="0">
+                        <a:latin typeface="Calibri" charset="0"/>
+                        <a:ea typeface="Calibri" charset="0"/>
+                        <a:cs typeface="Calibri" charset="0"/>
+                      </a:endParaRPr>
+                    </a:p>
+                  </a:txBody>
+                  <a:tcPr marL="91440" marR="91440" marT="45720" marB="45720" anchor="ctr">
+                    <a:lnL w="12700" cap="flat" cmpd="sng" algn="ctr">
+                      <a:solidFill>
+                        <a:srgbClr val="D8DCEC"/>
+                      </a:solidFill>
+                      <a:prstDash val="solid"/>
+                      <a:round/>
+                      <a:headEnd type="none" w="med" len="med"/>
+                      <a:tailEnd type="none" w="med" len="med"/>
+                    </a:lnL>
+                    <a:lnR w="12700" cap="flat" cmpd="sng" algn="ctr">
+                      <a:solidFill>
+                        <a:srgbClr val="D8DCEC"/>
+                      </a:solidFill>
+                      <a:prstDash val="solid"/>
+                      <a:round/>
+                      <a:headEnd type="none" w="med" len="med"/>
+                      <a:tailEnd type="none" w="med" len="med"/>
+                    </a:lnR>
+                    <a:lnT w="12700" cap="flat" cmpd="sng" algn="ctr">
+                      <a:solidFill>
+                        <a:srgbClr val="D8DCEC"/>
+                      </a:solidFill>
+                      <a:prstDash val="solid"/>
+                      <a:round/>
+                      <a:headEnd type="none" w="med" len="med"/>
+                      <a:tailEnd type="none" w="med" len="med"/>
+                    </a:lnT>
+                    <a:lnB w="12700" cap="flat" cmpd="sng" algn="ctr">
+                      <a:solidFill>
+                        <a:srgbClr val="D8DCEC"/>
+                      </a:solidFill>
+                      <a:prstDash val="solid"/>
+                      <a:round/>
+                      <a:headEnd type="none" w="med" len="med"/>
+                      <a:tailEnd type="none" w="med" len="med"/>
+                    </a:lnB>
+                  </a:tcPr>
+                </a:tc>
+                <a:tc>
+                  <a:txBody>
+                    <a:bodyPr/>
+                    <a:lstStyle/>
+                    <a:p>
+                      <a:pPr indent="0" marL="0">
+                        <a:buNone/>
+                      </a:pPr>
+                      <a:r>
+                        <a:rPr lang="en-US" sz="1050" dirty="0">
+                          <a:solidFill>
+                            <a:srgbClr val="1A1D29"/>
+                          </a:solidFill>
+                          <a:latin typeface="Calibri" pitchFamily="34" charset="0"/>
+                          <a:ea typeface="Calibri" pitchFamily="34" charset="-122"/>
+                          <a:cs typeface="Calibri" pitchFamily="34" charset="-120"/>
+                        </a:rPr>
+                        <a:t>55 / 56 (98%)</a:t>
+                      </a:r>
+                      <a:endParaRPr lang="en-US" sz="1050" dirty="0">
+                        <a:latin typeface="Calibri" charset="0"/>
+                        <a:ea typeface="Calibri" charset="0"/>
+                        <a:cs typeface="Calibri" charset="0"/>
+                      </a:endParaRPr>
+                    </a:p>
+                  </a:txBody>
+                  <a:tcPr marL="91440" marR="91440" marT="45720" marB="45720" anchor="ctr">
+                    <a:lnL w="12700" cap="flat" cmpd="sng" algn="ctr">
+                      <a:solidFill>
+                        <a:srgbClr val="D8DCEC"/>
+                      </a:solidFill>
+                      <a:prstDash val="solid"/>
+                      <a:round/>
+                      <a:headEnd type="none" w="med" len="med"/>
+                      <a:tailEnd type="none" w="med" len="med"/>
+                    </a:lnL>
+                    <a:lnR w="12700" cap="flat" cmpd="sng" algn="ctr">
+                      <a:solidFill>
+                        <a:srgbClr val="D8DCEC"/>
+                      </a:solidFill>
+                      <a:prstDash val="solid"/>
+                      <a:round/>
+                      <a:headEnd type="none" w="med" len="med"/>
+                      <a:tailEnd type="none" w="med" len="med"/>
+                    </a:lnR>
+                    <a:lnT w="12700" cap="flat" cmpd="sng" algn="ctr">
+                      <a:solidFill>
+                        <a:srgbClr val="D8DCEC"/>
+                      </a:solidFill>
+                      <a:prstDash val="solid"/>
+                      <a:round/>
+                      <a:headEnd type="none" w="med" len="med"/>
+                      <a:tailEnd type="none" w="med" len="med"/>
+                    </a:lnT>
+                    <a:lnB w="12700" cap="flat" cmpd="sng" algn="ctr">
+                      <a:solidFill>
+                        <a:srgbClr val="D8DCEC"/>
+                      </a:solidFill>
+                      <a:prstDash val="solid"/>
+                      <a:round/>
+                      <a:headEnd type="none" w="med" len="med"/>
+                      <a:tailEnd type="none" w="med" len="med"/>
+                    </a:lnB>
+                  </a:tcPr>
+                </a:tc>
+                <a:tc>
+                  <a:txBody>
+                    <a:bodyPr/>
+                    <a:lstStyle/>
+                    <a:p>
+                      <a:pPr indent="0" marL="0">
+                        <a:buNone/>
+                      </a:pPr>
+                      <a:r>
+                        <a:rPr lang="en-US" sz="1050" b="1" dirty="0">
+                          <a:solidFill>
+                            <a:srgbClr val="2E9E5B"/>
+                          </a:solidFill>
+                          <a:latin typeface="Calibri" pitchFamily="34" charset="0"/>
+                          <a:ea typeface="Calibri" pitchFamily="34" charset="-122"/>
+                          <a:cs typeface="Calibri" pitchFamily="34" charset="-120"/>
+                        </a:rPr>
+                        <a:t>Coherent, cited</a:t>
+                      </a:r>
+                      <a:endParaRPr lang="en-US" sz="1050" dirty="0">
+                        <a:latin typeface="Calibri" charset="0"/>
+                        <a:ea typeface="Calibri" charset="0"/>
+                        <a:cs typeface="Calibri" charset="0"/>
+                      </a:endParaRPr>
+                    </a:p>
+                  </a:txBody>
+                  <a:tcPr marL="91440" marR="91440" marT="45720" marB="45720" anchor="ctr">
+                    <a:lnL w="12700" cap="flat" cmpd="sng" algn="ctr">
+                      <a:solidFill>
+                        <a:srgbClr val="D8DCEC"/>
+                      </a:solidFill>
+                      <a:prstDash val="solid"/>
+                      <a:round/>
+                      <a:headEnd type="none" w="med" len="med"/>
+                      <a:tailEnd type="none" w="med" len="med"/>
+                    </a:lnL>
+                    <a:lnR w="12700" cap="flat" cmpd="sng" algn="ctr">
+                      <a:solidFill>
+                        <a:srgbClr val="D8DCEC"/>
+                      </a:solidFill>
+                      <a:prstDash val="solid"/>
+                      <a:round/>
+                      <a:headEnd type="none" w="med" len="med"/>
+                      <a:tailEnd type="none" w="med" len="med"/>
+                    </a:lnR>
+                    <a:lnT w="12700" cap="flat" cmpd="sng" algn="ctr">
+                      <a:solidFill>
+                        <a:srgbClr val="D8DCEC"/>
+                      </a:solidFill>
+                      <a:prstDash val="solid"/>
+                      <a:round/>
+                      <a:headEnd type="none" w="med" len="med"/>
+                      <a:tailEnd type="none" w="med" len="med"/>
+                    </a:lnT>
+                    <a:lnB w="12700" cap="flat" cmpd="sng" algn="ctr">
+                      <a:solidFill>
+                        <a:srgbClr val="D8DCEC"/>
+                      </a:solidFill>
+                      <a:prstDash val="solid"/>
+                      <a:round/>
+                      <a:headEnd type="none" w="med" len="med"/>
+                      <a:tailEnd type="none" w="med" len="med"/>
+                    </a:lnB>
+                  </a:tcPr>
+                </a:tc>
+              </a:tr>
+              <a:tr h="384048">
+                <a:tc>
+                  <a:txBody>
+                    <a:bodyPr/>
+                    <a:lstStyle/>
+                    <a:p>
+                      <a:pPr indent="0" marL="0">
+                        <a:buNone/>
+                      </a:pPr>
+                      <a:r>
+                        <a:rPr lang="en-US" sz="1100" b="1" dirty="0">
+                          <a:solidFill>
+                            <a:srgbClr val="1A1D29"/>
+                          </a:solidFill>
+                          <a:latin typeface="Calibri" pitchFamily="34" charset="0"/>
+                          <a:ea typeface="Calibri" pitchFamily="34" charset="-122"/>
+                          <a:cs typeface="Calibri" pitchFamily="34" charset="-120"/>
+                        </a:rPr>
+                        <a:t>Vlog / Talking-Head</a:t>
+                      </a:r>
+                      <a:pPr indent="0" marL="0">
+                        <a:buNone/>
+                      </a:pPr>
+                      <a:r>
+                        <a:rPr lang="en-US" sz="900" i="1" dirty="0">
+                          <a:solidFill>
+                            <a:srgbClr val="5B6072"/>
+                          </a:solidFill>
+                          <a:latin typeface="Calibri" pitchFamily="34" charset="0"/>
+                          <a:ea typeface="Calibri" pitchFamily="34" charset="-122"/>
+                          <a:cs typeface="Calibri" pitchFamily="34" charset="-120"/>
+                        </a:rPr>
+                        <a:t>  (1 of 2)</a:t>
+                      </a:r>
+                      <a:endParaRPr lang="en-US" sz="1050" dirty="0">
+                        <a:latin typeface="Calibri" charset="0"/>
+                        <a:ea typeface="Calibri" charset="0"/>
+                        <a:cs typeface="Calibri" charset="0"/>
+                      </a:endParaRPr>
+                    </a:p>
+                  </a:txBody>
+                  <a:tcPr marL="91440" marR="91440" marT="45720" marB="45720" anchor="ctr">
+                    <a:lnL w="12700" cap="flat" cmpd="sng" algn="ctr">
+                      <a:solidFill>
+                        <a:srgbClr val="D8DCEC"/>
+                      </a:solidFill>
+                      <a:prstDash val="solid"/>
+                      <a:round/>
+                      <a:headEnd type="none" w="med" len="med"/>
+                      <a:tailEnd type="none" w="med" len="med"/>
+                    </a:lnL>
+                    <a:lnR w="12700" cap="flat" cmpd="sng" algn="ctr">
+                      <a:solidFill>
+                        <a:srgbClr val="D8DCEC"/>
+                      </a:solidFill>
+                      <a:prstDash val="solid"/>
+                      <a:round/>
+                      <a:headEnd type="none" w="med" len="med"/>
+                      <a:tailEnd type="none" w="med" len="med"/>
+                    </a:lnR>
+                    <a:lnT w="12700" cap="flat" cmpd="sng" algn="ctr">
+                      <a:solidFill>
+                        <a:srgbClr val="D8DCEC"/>
+                      </a:solidFill>
+                      <a:prstDash val="solid"/>
+                      <a:round/>
+                      <a:headEnd type="none" w="med" len="med"/>
+                      <a:tailEnd type="none" w="med" len="med"/>
+                    </a:lnT>
+                    <a:lnB w="12700" cap="flat" cmpd="sng" algn="ctr">
+                      <a:solidFill>
+                        <a:srgbClr val="D8DCEC"/>
+                      </a:solidFill>
+                      <a:prstDash val="solid"/>
+                      <a:round/>
+                      <a:headEnd type="none" w="med" len="med"/>
+                      <a:tailEnd type="none" w="med" len="med"/>
+                    </a:lnB>
+                  </a:tcPr>
+                </a:tc>
+                <a:tc>
+                  <a:txBody>
+                    <a:bodyPr/>
+                    <a:lstStyle/>
+                    <a:p>
+                      <a:pPr indent="0" marL="0">
+                        <a:buNone/>
+                      </a:pPr>
+                      <a:r>
+                        <a:rPr lang="en-US" sz="1050" dirty="0">
+                          <a:solidFill>
+                            <a:srgbClr val="1A1D29"/>
+                          </a:solidFill>
+                          <a:latin typeface="Calibri" pitchFamily="34" charset="0"/>
+                          <a:ea typeface="Calibri" pitchFamily="34" charset="-122"/>
+                          <a:cs typeface="Calibri" pitchFamily="34" charset="-120"/>
+                        </a:rPr>
+                        <a:t>“What I Eat In a Day”</a:t>
+                      </a:r>
+                      <a:endParaRPr lang="en-US" sz="1050" dirty="0">
+                        <a:latin typeface="Calibri" charset="0"/>
+                        <a:ea typeface="Calibri" charset="0"/>
+                        <a:cs typeface="Calibri" charset="0"/>
+                      </a:endParaRPr>
+                    </a:p>
+                  </a:txBody>
+                  <a:tcPr marL="91440" marR="91440" marT="45720" marB="45720" anchor="ctr">
+                    <a:lnL w="12700" cap="flat" cmpd="sng" algn="ctr">
+                      <a:solidFill>
+                        <a:srgbClr val="D8DCEC"/>
+                      </a:solidFill>
+                      <a:prstDash val="solid"/>
+                      <a:round/>
+                      <a:headEnd type="none" w="med" len="med"/>
+                      <a:tailEnd type="none" w="med" len="med"/>
+                    </a:lnL>
+                    <a:lnR w="12700" cap="flat" cmpd="sng" algn="ctr">
+                      <a:solidFill>
+                        <a:srgbClr val="D8DCEC"/>
+                      </a:solidFill>
+                      <a:prstDash val="solid"/>
+                      <a:round/>
+                      <a:headEnd type="none" w="med" len="med"/>
+                      <a:tailEnd type="none" w="med" len="med"/>
+                    </a:lnR>
+                    <a:lnT w="12700" cap="flat" cmpd="sng" algn="ctr">
+                      <a:solidFill>
+                        <a:srgbClr val="D8DCEC"/>
+                      </a:solidFill>
+                      <a:prstDash val="solid"/>
+                      <a:round/>
+                      <a:headEnd type="none" w="med" len="med"/>
+                      <a:tailEnd type="none" w="med" len="med"/>
+                    </a:lnT>
+                    <a:lnB w="12700" cap="flat" cmpd="sng" algn="ctr">
+                      <a:solidFill>
+                        <a:srgbClr val="D8DCEC"/>
+                      </a:solidFill>
+                      <a:prstDash val="solid"/>
+                      <a:round/>
+                      <a:headEnd type="none" w="med" len="med"/>
+                      <a:tailEnd type="none" w="med" len="med"/>
+                    </a:lnB>
+                  </a:tcPr>
+                </a:tc>
+                <a:tc>
+                  <a:txBody>
+                    <a:bodyPr/>
+                    <a:lstStyle/>
+                    <a:p>
+                      <a:pPr indent="0" marL="0">
+                        <a:buNone/>
+                      </a:pPr>
+                      <a:r>
+                        <a:rPr lang="en-US" sz="1050" dirty="0">
+                          <a:solidFill>
+                            <a:srgbClr val="1A1D29"/>
+                          </a:solidFill>
+                          <a:latin typeface="Calibri" pitchFamily="34" charset="0"/>
+                          <a:ea typeface="Calibri" pitchFamily="34" charset="-122"/>
+                          <a:cs typeface="Calibri" pitchFamily="34" charset="-120"/>
+                        </a:rPr>
+                        <a:t>13m 0s</a:t>
+                      </a:r>
+                      <a:endParaRPr lang="en-US" sz="1050" dirty="0">
+                        <a:latin typeface="Calibri" charset="0"/>
+                        <a:ea typeface="Calibri" charset="0"/>
+                        <a:cs typeface="Calibri" charset="0"/>
+                      </a:endParaRPr>
+                    </a:p>
+                  </a:txBody>
+                  <a:tcPr marL="91440" marR="91440" marT="45720" marB="45720" anchor="ctr">
+                    <a:lnL w="12700" cap="flat" cmpd="sng" algn="ctr">
+                      <a:solidFill>
+                        <a:srgbClr val="D8DCEC"/>
+                      </a:solidFill>
+                      <a:prstDash val="solid"/>
+                      <a:round/>
+                      <a:headEnd type="none" w="med" len="med"/>
+                      <a:tailEnd type="none" w="med" len="med"/>
+                    </a:lnL>
+                    <a:lnR w="12700" cap="flat" cmpd="sng" algn="ctr">
+                      <a:solidFill>
+                        <a:srgbClr val="D8DCEC"/>
+                      </a:solidFill>
+                      <a:prstDash val="solid"/>
+                      <a:round/>
+                      <a:headEnd type="none" w="med" len="med"/>
+                      <a:tailEnd type="none" w="med" len="med"/>
+                    </a:lnR>
+                    <a:lnT w="12700" cap="flat" cmpd="sng" algn="ctr">
+                      <a:solidFill>
+                        <a:srgbClr val="D8DCEC"/>
+                      </a:solidFill>
+                      <a:prstDash val="solid"/>
+                      <a:round/>
+                      <a:headEnd type="none" w="med" len="med"/>
+                      <a:tailEnd type="none" w="med" len="med"/>
+                    </a:lnT>
+                    <a:lnB w="12700" cap="flat" cmpd="sng" algn="ctr">
+                      <a:solidFill>
+                        <a:srgbClr val="D8DCEC"/>
+                      </a:solidFill>
+                      <a:prstDash val="solid"/>
+                      <a:round/>
+                      <a:headEnd type="none" w="med" len="med"/>
+                      <a:tailEnd type="none" w="med" len="med"/>
+                    </a:lnB>
+                  </a:tcPr>
+                </a:tc>
+                <a:tc>
+                  <a:txBody>
+                    <a:bodyPr/>
+                    <a:lstStyle/>
+                    <a:p>
+                      <a:pPr indent="0" marL="0">
+                        <a:buNone/>
+                      </a:pPr>
+                      <a:r>
+                        <a:rPr lang="en-US" sz="1050" dirty="0">
+                          <a:solidFill>
+                            <a:srgbClr val="1A1D29"/>
+                          </a:solidFill>
+                          <a:latin typeface="Calibri" pitchFamily="34" charset="0"/>
+                          <a:ea typeface="Calibri" pitchFamily="34" charset="-122"/>
+                          <a:cs typeface="Calibri" pitchFamily="34" charset="-120"/>
+                        </a:rPr>
+                        <a:t>146 / 156 (94%)</a:t>
+                      </a:r>
+                      <a:endParaRPr lang="en-US" sz="1050" dirty="0">
+                        <a:latin typeface="Calibri" charset="0"/>
+                        <a:ea typeface="Calibri" charset="0"/>
+                        <a:cs typeface="Calibri" charset="0"/>
+                      </a:endParaRPr>
+                    </a:p>
+                  </a:txBody>
+                  <a:tcPr marL="91440" marR="91440" marT="45720" marB="45720" anchor="ctr">
+                    <a:lnL w="12700" cap="flat" cmpd="sng" algn="ctr">
+                      <a:solidFill>
+                        <a:srgbClr val="D8DCEC"/>
+                      </a:solidFill>
+                      <a:prstDash val="solid"/>
+                      <a:round/>
+                      <a:headEnd type="none" w="med" len="med"/>
+                      <a:tailEnd type="none" w="med" len="med"/>
+                    </a:lnL>
+                    <a:lnR w="12700" cap="flat" cmpd="sng" algn="ctr">
+                      <a:solidFill>
+                        <a:srgbClr val="D8DCEC"/>
+                      </a:solidFill>
+                      <a:prstDash val="solid"/>
+                      <a:round/>
+                      <a:headEnd type="none" w="med" len="med"/>
+                      <a:tailEnd type="none" w="med" len="med"/>
+                    </a:lnR>
+                    <a:lnT w="12700" cap="flat" cmpd="sng" algn="ctr">
+                      <a:solidFill>
+                        <a:srgbClr val="D8DCEC"/>
+                      </a:solidFill>
+                      <a:prstDash val="solid"/>
+                      <a:round/>
+                      <a:headEnd type="none" w="med" len="med"/>
+                      <a:tailEnd type="none" w="med" len="med"/>
+                    </a:lnT>
+                    <a:lnB w="12700" cap="flat" cmpd="sng" algn="ctr">
+                      <a:solidFill>
+                        <a:srgbClr val="D8DCEC"/>
+                      </a:solidFill>
+                      <a:prstDash val="solid"/>
+                      <a:round/>
+                      <a:headEnd type="none" w="med" len="med"/>
+                      <a:tailEnd type="none" w="med" len="med"/>
+                    </a:lnB>
+                  </a:tcPr>
+                </a:tc>
+                <a:tc>
+                  <a:txBody>
+                    <a:bodyPr/>
+                    <a:lstStyle/>
+                    <a:p>
+                      <a:pPr indent="0" marL="0">
+                        <a:buNone/>
+                      </a:pPr>
+                      <a:r>
+                        <a:rPr lang="en-US" sz="1050" dirty="0">
+                          <a:solidFill>
+                            <a:srgbClr val="B8860B"/>
+                          </a:solidFill>
+                          <a:latin typeface="Calibri" pitchFamily="34" charset="0"/>
+                          <a:ea typeface="Calibri" pitchFamily="34" charset="-122"/>
+                          <a:cs typeface="Calibri" pitchFamily="34" charset="-120"/>
+                        </a:rPr>
+                        <a:t>Coherent, minor self-contradiction</a:t>
+                      </a:r>
+                      <a:endParaRPr lang="en-US" sz="1050" dirty="0">
+                        <a:latin typeface="Calibri" charset="0"/>
+                        <a:ea typeface="Calibri" charset="0"/>
+                        <a:cs typeface="Calibri" charset="0"/>
+                      </a:endParaRPr>
+                    </a:p>
+                  </a:txBody>
+                  <a:tcPr marL="91440" marR="91440" marT="45720" marB="45720" anchor="ctr">
+                    <a:lnL w="12700" cap="flat" cmpd="sng" algn="ctr">
+                      <a:solidFill>
+                        <a:srgbClr val="D8DCEC"/>
+                      </a:solidFill>
+                      <a:prstDash val="solid"/>
+                      <a:round/>
+                      <a:headEnd type="none" w="med" len="med"/>
+                      <a:tailEnd type="none" w="med" len="med"/>
+                    </a:lnL>
+                    <a:lnR w="12700" cap="flat" cmpd="sng" algn="ctr">
+                      <a:solidFill>
+                        <a:srgbClr val="D8DCEC"/>
+                      </a:solidFill>
+                      <a:prstDash val="solid"/>
+                      <a:round/>
+                      <a:headEnd type="none" w="med" len="med"/>
+                      <a:tailEnd type="none" w="med" len="med"/>
+                    </a:lnR>
+                    <a:lnT w="12700" cap="flat" cmpd="sng" algn="ctr">
+                      <a:solidFill>
+                        <a:srgbClr val="D8DCEC"/>
+                      </a:solidFill>
+                      <a:prstDash val="solid"/>
+                      <a:round/>
+                      <a:headEnd type="none" w="med" len="med"/>
+                      <a:tailEnd type="none" w="med" len="med"/>
+                    </a:lnT>
+                    <a:lnB w="12700" cap="flat" cmpd="sng" algn="ctr">
+                      <a:solidFill>
+                        <a:srgbClr val="D8DCEC"/>
+                      </a:solidFill>
+                      <a:prstDash val="solid"/>
+                      <a:round/>
+                      <a:headEnd type="none" w="med" len="med"/>
+                      <a:tailEnd type="none" w="med" len="med"/>
+                    </a:lnB>
+                  </a:tcPr>
+                </a:tc>
+              </a:tr>
+              <a:tr h="384048">
+                <a:tc>
+                  <a:txBody>
+                    <a:bodyPr/>
+                    <a:lstStyle/>
+                    <a:p>
+                      <a:pPr indent="0" marL="0">
+                        <a:buNone/>
+                      </a:pPr>
+                      <a:r>
+                        <a:rPr lang="en-US" sz="1100" i="1" dirty="0">
+                          <a:solidFill>
+                            <a:srgbClr val="5B6072"/>
+                          </a:solidFill>
+                          <a:latin typeface="Calibri" pitchFamily="34" charset="0"/>
+                          <a:ea typeface="Calibri" pitchFamily="34" charset="-122"/>
+                          <a:cs typeface="Calibri" pitchFamily="34" charset="-120"/>
+                        </a:rPr>
+                        <a:t>Sports / Live Commentary</a:t>
+                      </a:r>
+                      <a:pPr indent="0" marL="0">
+                        <a:buNone/>
+                      </a:pPr>
+                      <a:r>
+                        <a:rPr lang="en-US" sz="900" i="1" dirty="0">
+                          <a:solidFill>
+                            <a:srgbClr val="5B6072"/>
+                          </a:solidFill>
+                          <a:latin typeface="Calibri" pitchFamily="34" charset="0"/>
+                          <a:ea typeface="Calibri" pitchFamily="34" charset="-122"/>
+                          <a:cs typeface="Calibri" pitchFamily="34" charset="-120"/>
+                        </a:rPr>
+                        <a:t>  (0 of 2)</a:t>
+                      </a:r>
+                      <a:endParaRPr lang="en-US" sz="1050" dirty="0">
+                        <a:latin typeface="Calibri" charset="0"/>
+                        <a:ea typeface="Calibri" charset="0"/>
+                        <a:cs typeface="Calibri" charset="0"/>
+                      </a:endParaRPr>
+                    </a:p>
+                  </a:txBody>
+                  <a:tcPr marL="91440" marR="91440" marT="45720" marB="45720" anchor="ctr">
+                    <a:lnL w="12700" cap="flat" cmpd="sng" algn="ctr">
+                      <a:solidFill>
+                        <a:srgbClr val="D8DCEC"/>
+                      </a:solidFill>
+                      <a:prstDash val="solid"/>
+                      <a:round/>
+                      <a:headEnd type="none" w="med" len="med"/>
+                      <a:tailEnd type="none" w="med" len="med"/>
+                    </a:lnL>
+                    <a:lnR w="12700" cap="flat" cmpd="sng" algn="ctr">
+                      <a:solidFill>
+                        <a:srgbClr val="D8DCEC"/>
+                      </a:solidFill>
+                      <a:prstDash val="solid"/>
+                      <a:round/>
+                      <a:headEnd type="none" w="med" len="med"/>
+                      <a:tailEnd type="none" w="med" len="med"/>
+                    </a:lnR>
+                    <a:lnT w="12700" cap="flat" cmpd="sng" algn="ctr">
+                      <a:solidFill>
+                        <a:srgbClr val="D8DCEC"/>
+                      </a:solidFill>
+                      <a:prstDash val="solid"/>
+                      <a:round/>
+                      <a:headEnd type="none" w="med" len="med"/>
+                      <a:tailEnd type="none" w="med" len="med"/>
+                    </a:lnT>
+                    <a:lnB w="12700" cap="flat" cmpd="sng" algn="ctr">
+                      <a:solidFill>
+                        <a:srgbClr val="D8DCEC"/>
+                      </a:solidFill>
+                      <a:prstDash val="solid"/>
+                      <a:round/>
+                      <a:headEnd type="none" w="med" len="med"/>
+                      <a:tailEnd type="none" w="med" len="med"/>
+                    </a:lnB>
+                  </a:tcPr>
+                </a:tc>
+                <a:tc>
+                  <a:txBody>
+                    <a:bodyPr/>
+                    <a:lstStyle/>
+                    <a:p>
+                      <a:pPr indent="0" marL="0">
+                        <a:buNone/>
+                      </a:pPr>
+                      <a:r>
+                        <a:rPr lang="en-US" sz="1050" i="1" dirty="0">
+                          <a:solidFill>
+                            <a:srgbClr val="5B6072"/>
+                          </a:solidFill>
+                          <a:latin typeface="Calibri" pitchFamily="34" charset="0"/>
+                          <a:ea typeface="Calibri" pitchFamily="34" charset="-122"/>
+                          <a:cs typeface="Calibri" pitchFamily="34" charset="-120"/>
+                        </a:rPr>
+                        <a:t>— pending —</a:t>
+                      </a:r>
+                      <a:endParaRPr lang="en-US" sz="1050" dirty="0">
+                        <a:latin typeface="Calibri" charset="0"/>
+                        <a:ea typeface="Calibri" charset="0"/>
+                        <a:cs typeface="Calibri" charset="0"/>
+                      </a:endParaRPr>
+                    </a:p>
+                  </a:txBody>
+                  <a:tcPr marL="91440" marR="91440" marT="45720" marB="45720" anchor="ctr">
+                    <a:lnL w="12700" cap="flat" cmpd="sng" algn="ctr">
+                      <a:solidFill>
+                        <a:srgbClr val="D8DCEC"/>
+                      </a:solidFill>
+                      <a:prstDash val="solid"/>
+                      <a:round/>
+                      <a:headEnd type="none" w="med" len="med"/>
+                      <a:tailEnd type="none" w="med" len="med"/>
+                    </a:lnL>
+                    <a:lnR w="12700" cap="flat" cmpd="sng" algn="ctr">
+                      <a:solidFill>
+                        <a:srgbClr val="D8DCEC"/>
+                      </a:solidFill>
+                      <a:prstDash val="solid"/>
+                      <a:round/>
+                      <a:headEnd type="none" w="med" len="med"/>
+                      <a:tailEnd type="none" w="med" len="med"/>
+                    </a:lnR>
+                    <a:lnT w="12700" cap="flat" cmpd="sng" algn="ctr">
+                      <a:solidFill>
+                        <a:srgbClr val="D8DCEC"/>
+                      </a:solidFill>
+                      <a:prstDash val="solid"/>
+                      <a:round/>
+                      <a:headEnd type="none" w="med" len="med"/>
+                      <a:tailEnd type="none" w="med" len="med"/>
+                    </a:lnT>
+                    <a:lnB w="12700" cap="flat" cmpd="sng" algn="ctr">
+                      <a:solidFill>
+                        <a:srgbClr val="D8DCEC"/>
+                      </a:solidFill>
+                      <a:prstDash val="solid"/>
+                      <a:round/>
+                      <a:headEnd type="none" w="med" len="med"/>
+                      <a:tailEnd type="none" w="med" len="med"/>
+                    </a:lnB>
+                  </a:tcPr>
+                </a:tc>
+                <a:tc>
+                  <a:txBody>
+                    <a:bodyPr/>
+                    <a:lstStyle/>
+                    <a:p>
+                      <a:pPr indent="0" marL="0">
+                        <a:buNone/>
+                      </a:pPr>
+                      <a:r>
+                        <a:rPr lang="en-US" sz="1050" i="1" dirty="0">
+                          <a:solidFill>
+                            <a:srgbClr val="5B6072"/>
+                          </a:solidFill>
+                          <a:latin typeface="Calibri" pitchFamily="34" charset="0"/>
+                          <a:ea typeface="Calibri" pitchFamily="34" charset="-122"/>
+                          <a:cs typeface="Calibri" pitchFamily="34" charset="-120"/>
+                        </a:rPr>
+                        <a:t>—</a:t>
+                      </a:r>
+                      <a:endParaRPr lang="en-US" sz="1050" dirty="0">
+                        <a:latin typeface="Calibri" charset="0"/>
+                        <a:ea typeface="Calibri" charset="0"/>
+                        <a:cs typeface="Calibri" charset="0"/>
+                      </a:endParaRPr>
+                    </a:p>
+                  </a:txBody>
+                  <a:tcPr marL="91440" marR="91440" marT="45720" marB="45720" anchor="ctr">
+                    <a:lnL w="12700" cap="flat" cmpd="sng" algn="ctr">
+                      <a:solidFill>
+                        <a:srgbClr val="D8DCEC"/>
+                      </a:solidFill>
+                      <a:prstDash val="solid"/>
+                      <a:round/>
+                      <a:headEnd type="none" w="med" len="med"/>
+                      <a:tailEnd type="none" w="med" len="med"/>
+                    </a:lnL>
+                    <a:lnR w="12700" cap="flat" cmpd="sng" algn="ctr">
+                      <a:solidFill>
+                        <a:srgbClr val="D8DCEC"/>
+                      </a:solidFill>
+                      <a:prstDash val="solid"/>
+                      <a:round/>
+                      <a:headEnd type="none" w="med" len="med"/>
+                      <a:tailEnd type="none" w="med" len="med"/>
+                    </a:lnR>
+                    <a:lnT w="12700" cap="flat" cmpd="sng" algn="ctr">
+                      <a:solidFill>
+                        <a:srgbClr val="D8DCEC"/>
+                      </a:solidFill>
+                      <a:prstDash val="solid"/>
+                      <a:round/>
+                      <a:headEnd type="none" w="med" len="med"/>
+                      <a:tailEnd type="none" w="med" len="med"/>
+                    </a:lnT>
+                    <a:lnB w="12700" cap="flat" cmpd="sng" algn="ctr">
+                      <a:solidFill>
+                        <a:srgbClr val="D8DCEC"/>
+                      </a:solidFill>
+                      <a:prstDash val="solid"/>
+                      <a:round/>
+                      <a:headEnd type="none" w="med" len="med"/>
+                      <a:tailEnd type="none" w="med" len="med"/>
+                    </a:lnB>
+                  </a:tcPr>
+                </a:tc>
+                <a:tc>
+                  <a:txBody>
+                    <a:bodyPr/>
+                    <a:lstStyle/>
+                    <a:p>
+                      <a:pPr indent="0" marL="0">
+                        <a:buNone/>
+                      </a:pPr>
+                      <a:r>
+                        <a:rPr lang="en-US" sz="1050" i="1" dirty="0">
+                          <a:solidFill>
+                            <a:srgbClr val="5B6072"/>
+                          </a:solidFill>
+                          <a:latin typeface="Calibri" pitchFamily="34" charset="0"/>
+                          <a:ea typeface="Calibri" pitchFamily="34" charset="-122"/>
+                          <a:cs typeface="Calibri" pitchFamily="34" charset="-120"/>
+                        </a:rPr>
+                        <a:t>—</a:t>
+                      </a:r>
+                      <a:endParaRPr lang="en-US" sz="1050" dirty="0">
+                        <a:latin typeface="Calibri" charset="0"/>
+                        <a:ea typeface="Calibri" charset="0"/>
+                        <a:cs typeface="Calibri" charset="0"/>
+                      </a:endParaRPr>
+                    </a:p>
+                  </a:txBody>
+                  <a:tcPr marL="91440" marR="91440" marT="45720" marB="45720" anchor="ctr">
+                    <a:lnL w="12700" cap="flat" cmpd="sng" algn="ctr">
+                      <a:solidFill>
+                        <a:srgbClr val="D8DCEC"/>
+                      </a:solidFill>
+                      <a:prstDash val="solid"/>
+                      <a:round/>
+                      <a:headEnd type="none" w="med" len="med"/>
+                      <a:tailEnd type="none" w="med" len="med"/>
+                    </a:lnL>
+                    <a:lnR w="12700" cap="flat" cmpd="sng" algn="ctr">
+                      <a:solidFill>
+                        <a:srgbClr val="D8DCEC"/>
+                      </a:solidFill>
+                      <a:prstDash val="solid"/>
+                      <a:round/>
+                      <a:headEnd type="none" w="med" len="med"/>
+                      <a:tailEnd type="none" w="med" len="med"/>
+                    </a:lnR>
+                    <a:lnT w="12700" cap="flat" cmpd="sng" algn="ctr">
+                      <a:solidFill>
+                        <a:srgbClr val="D8DCEC"/>
+                      </a:solidFill>
+                      <a:prstDash val="solid"/>
+                      <a:round/>
+                      <a:headEnd type="none" w="med" len="med"/>
+                      <a:tailEnd type="none" w="med" len="med"/>
+                    </a:lnT>
+                    <a:lnB w="12700" cap="flat" cmpd="sng" algn="ctr">
+                      <a:solidFill>
+                        <a:srgbClr val="D8DCEC"/>
+                      </a:solidFill>
+                      <a:prstDash val="solid"/>
+                      <a:round/>
+                      <a:headEnd type="none" w="med" len="med"/>
+                      <a:tailEnd type="none" w="med" len="med"/>
+                    </a:lnB>
+                  </a:tcPr>
+                </a:tc>
+                <a:tc>
+                  <a:txBody>
+                    <a:bodyPr/>
+                    <a:lstStyle/>
+                    <a:p>
+                      <a:pPr indent="0" marL="0">
+                        <a:buNone/>
+                      </a:pPr>
+                      <a:r>
+                        <a:rPr lang="en-US" sz="1050" i="1" dirty="0">
+                          <a:solidFill>
+                            <a:srgbClr val="5B6072"/>
+                          </a:solidFill>
+                          <a:latin typeface="Calibri" pitchFamily="34" charset="0"/>
+                          <a:ea typeface="Calibri" pitchFamily="34" charset="-122"/>
+                          <a:cs typeface="Calibri" pitchFamily="34" charset="-120"/>
+                        </a:rPr>
+                        <a:t>— pending —</a:t>
+                      </a:r>
+                      <a:endParaRPr lang="en-US" sz="1050" dirty="0">
+                        <a:latin typeface="Calibri" charset="0"/>
+                        <a:ea typeface="Calibri" charset="0"/>
+                        <a:cs typeface="Calibri" charset="0"/>
+                      </a:endParaRPr>
+                    </a:p>
+                  </a:txBody>
+                  <a:tcPr marL="91440" marR="91440" marT="45720" marB="45720" anchor="ctr">
+                    <a:lnL w="12700" cap="flat" cmpd="sng" algn="ctr">
+                      <a:solidFill>
+                        <a:srgbClr val="D8DCEC"/>
+                      </a:solidFill>
+                      <a:prstDash val="solid"/>
+                      <a:round/>
+                      <a:headEnd type="none" w="med" len="med"/>
+                      <a:tailEnd type="none" w="med" len="med"/>
+                    </a:lnL>
+                    <a:lnR w="12700" cap="flat" cmpd="sng" algn="ctr">
+                      <a:solidFill>
+                        <a:srgbClr val="D8DCEC"/>
+                      </a:solidFill>
+                      <a:prstDash val="solid"/>
+                      <a:round/>
+                      <a:headEnd type="none" w="med" len="med"/>
+                      <a:tailEnd type="none" w="med" len="med"/>
+                    </a:lnR>
+                    <a:lnT w="12700" cap="flat" cmpd="sng" algn="ctr">
+                      <a:solidFill>
+                        <a:srgbClr val="D8DCEC"/>
+                      </a:solidFill>
+                      <a:prstDash val="solid"/>
+                      <a:round/>
+                      <a:headEnd type="none" w="med" len="med"/>
+                      <a:tailEnd type="none" w="med" len="med"/>
+                    </a:lnT>
+                    <a:lnB w="12700" cap="flat" cmpd="sng" algn="ctr">
+                      <a:solidFill>
+                        <a:srgbClr val="D8DCEC"/>
+                      </a:solidFill>
+                      <a:prstDash val="solid"/>
+                      <a:round/>
+                      <a:headEnd type="none" w="med" len="med"/>
+                      <a:tailEnd type="none" w="med" len="med"/>
+                    </a:lnB>
+                  </a:tcPr>
+                </a:tc>
+              </a:tr>
+            </a:tbl>
+          </a:graphicData>
+        </a:graphic>
+      </p:graphicFrame>
+      <p:sp>
+        <p:nvSpPr>
+          <p:cNvPr id="16" name="Text 13"/>
+          <p:cNvSpPr txBox="1"/>
+          <p:nvPr/>
+        </p:nvSpPr>
+        <p:spPr>
+          <a:xfrm>
+            <a:off x="548640" y="6053328"/>
+            <a:ext cx="11064240" cy="365760"/>
+          </a:xfrm>
+          <a:prstGeom prst="rect">
+            <a:avLst/>
+          </a:prstGeom>
+          <a:noFill/>
+          <a:ln/>
+        </p:spPr>
+        <p:txBody>
+          <a:bodyPr wrap="square" lIns="0" tIns="0" rIns="0" bIns="0" rtlCol="0" anchor="ctr"/>
+          <a:lstStyle/>
+          <a:p>
+            <a:pPr indent="0" marL="0">
+              <a:buNone/>
+            </a:pPr>
+            <a:r>
+              <a:rPr lang="en-US" sz="950" i="1" dirty="0">
+                <a:solidFill>
+                  <a:srgbClr val="5B6072"/>
+                </a:solidFill>
+                <a:latin typeface="Calibri" pitchFamily="34" charset="0"/>
+                <a:ea typeface="Calibri" pitchFamily="34" charset="-122"/>
+                <a:cs typeface="Calibri" pitchFamily="34" charset="-120"/>
+              </a:rPr>
+              <a:t>Frame-dedup keep-rate tracks visual staticness: 31% on lecture slides vs. 79–98% on genres with camera motion — real evidence motivating content-boundary (SSIM) detection over raw pixel-difference (see Next Steps).</a:t>
+            </a:r>
+            <a:endParaRPr lang="en-US" sz="950" dirty="0"/>
+          </a:p>
+        </p:txBody>
+      </p:sp>
+      <p:sp>
+        <p:nvSpPr>
+          <p:cNvPr id="17" name="Text 14"/>
           <p:cNvSpPr txBox="1"/>
           <p:nvPr/>
         </p:nvSpPr>

</xml_diff>